<commit_message>
Fix Lesson 3 deck: add missing robotPeriodic slide, tag code Try-It items
The addEventListener line was shown bare instead of in its constructor
context, and the trimmed robotPeriodic() body (dropping the old
logRunningCommand() call, per the doc's explicit bold-action block) was
never shown as a code card anywhere in the deck.

Also tag the three Try-It items that expect real code-writing (logging
commanded speed, getPositionRotations(), logging SchedulerEvent.Completed)
with the WRITE CODE pill in the deck and a bold Code lead-in in the
lesson doc, per house rule #10. The dashboard-key-rename item stays
untagged since it's a string swap, not new code.
</commit_message>
<xml_diff>
--- a/docs/presentations/v3/03-telemetry.pptx
+++ b/docs/presentations/v3/03-telemetry.pptx
@@ -15,9 +15,10 @@
     <p:sldId id="263" r:id="rId9"/>
     <p:sldId id="264" r:id="rId10"/>
     <p:sldId id="265" r:id="rId11"/>
+    <p:sldId id="266" r:id="rId12"/>
   </p:sldIdLst>
   <p:notesMasterIdLst>
-    <p:notesMasterId r:id="rId12"/>
+    <p:notesMasterId r:id="rId13"/>
   </p:notesMasterIdLst>
   <p:sldSz cx="12191695" cy="6858000"/>
   <p:notesSz cx="6858000" cy="12191695"/>
@@ -599,7 +600,7 @@
           <a:p>
             <a:r>
               <a:rPr lang="en-US" dirty="0"/>
-              <a:t>That naming discipline — Mechanism/Name — feels like overkill for two values; it stops being overkill around value twenty, and this course gets there sooner than it seems. The bigger shift is trading a poll for a listener: logRunningCommand() asked a question every tick and happened to always have an answer, but "happened to" isn't a guarantee. logCommandStart() doesn't ask at all — it registers once and reacts exactly when a SchedulerEvent.Scheduled actually occurs, unpacked with instanceof pattern matching. Same dashboard key, same string showing up, but nothing left that can come up empty. The plots look unimpressive while the sim motor stands still, but Lesson 4 turns the physics on, and these same plots come alive.</a:t>
+              <a:t>Logging the commanded speed is a refinement of the always-running rule from section 4: a value that only exists inside a command — like the command's own output — gets logged right where it's computed, not from a periodic callback. On a real robot, overlaying CommandedOutput against VelocityRotPerSec shows how the motor lags the command — the seed of understanding control, which pays off starting in Lesson 5. getPositionRotations() is worth calling out as exposing a reading method alongside command factories — that's fine, readings are safe to share, unlike commands. Renaming a dashboard key is a hands-on demonstration that the slash really is a folder path and the name really is the address — the old entry goes stale and a new folder appears in the tree. The SchedulerEvent.Completed exercise previews the vocabulary callout: Scheduled isn't the only kind of event.</a:t>
             </a:r>
             <a:endParaRPr lang="en-US" dirty="0"/>
           </a:p>
@@ -623,6 +624,94 @@
             <a:fld id="{F7021451-1387-4CA6-816F-3879F97B5CBC}" type="slidenum">
               <a:rPr lang="en-US"/>
               <a:t>10</a:t>
+            </a:fld>
+            <a:endParaRPr lang="en-US"/>
+          </a:p>
+        </p:txBody>
+      </p:sp>
+    </p:spTree>
+    <p:extLst>
+      <p:ext uri="{BB962C8B-B14F-4D97-AF65-F5344CB8AC3E}">
+        <p14:creationId xmlns:p14="http://schemas.microsoft.com/office/powerpoint/2010/main" val="1024086991"/>
+      </p:ext>
+    </p:extLst>
+  </p:cSld>
+  <p:clrMapOvr>
+    <a:masterClrMapping/>
+  </p:clrMapOvr>
+</p:notes>
+</file>
+
+<file path=ppt/notesSlides/notesSlide11.xml><?xml version="1.0" encoding="utf-8"?>
+<p:notes xmlns:a="http://schemas.openxmlformats.org/drawingml/2006/main" xmlns:r="http://schemas.openxmlformats.org/officeDocument/2006/relationships" xmlns:p="http://schemas.openxmlformats.org/presentationml/2006/main">
+  <p:cSld>
+    <p:spTree>
+      <p:nvGrpSpPr>
+        <p:cNvPr id="1" name=""/>
+        <p:cNvGrpSpPr/>
+        <p:nvPr/>
+      </p:nvGrpSpPr>
+      <p:grpSpPr>
+        <a:xfrm>
+          <a:off x="0" y="0"/>
+          <a:ext cx="0" cy="0"/>
+          <a:chOff x="0" y="0"/>
+          <a:chExt cx="0" cy="0"/>
+        </a:xfrm>
+      </p:grpSpPr>
+      <p:sp>
+        <p:nvSpPr>
+          <p:cNvPr id="2" name="Slide Image Placeholder 1"/>
+          <p:cNvSpPr>
+            <a:spLocks noGrp="1" noRot="1" noChangeAspect="1"/>
+          </p:cNvSpPr>
+          <p:nvPr>
+            <p:ph type="sldImg"/>
+          </p:nvPr>
+        </p:nvSpPr>
+        <p:spPr/>
+      </p:sp>
+      <p:sp>
+        <p:nvSpPr>
+          <p:cNvPr id="3" name="Notes Placeholder 2"/>
+          <p:cNvSpPr>
+            <a:spLocks noGrp="1"/>
+          </p:cNvSpPr>
+          <p:nvPr>
+            <p:ph type="body" idx="1"/>
+          </p:nvPr>
+        </p:nvSpPr>
+        <p:spPr/>
+        <p:txBody>
+          <a:bodyPr/>
+          <a:lstStyle/>
+          <a:p>
+            <a:r>
+              <a:rPr lang="en-US" dirty="0"/>
+              <a:t>That naming discipline — Mechanism/Name — feels like overkill for two values; it stops being overkill around value twenty, and this course gets there sooner than it seems. The bigger shift is trading a poll for a listener: logRunningCommand() asked a question every tick and happened to always have an answer, but "happened to" isn't a guarantee. logCommandStart() doesn't ask at all — it registers once and reacts exactly when a SchedulerEvent.Scheduled actually occurs, unpacked with instanceof pattern matching. Same dashboard key, same string showing up, but nothing left that can come up empty. The plots look unimpressive while the sim motor stands still, but Lesson 4 turns the physics on, and these same plots come alive.</a:t>
+            </a:r>
+            <a:endParaRPr lang="en-US" dirty="0"/>
+          </a:p>
+        </p:txBody>
+      </p:sp>
+      <p:sp>
+        <p:nvSpPr>
+          <p:cNvPr id="4" name="Slide Number Placeholder 3"/>
+          <p:cNvSpPr>
+            <a:spLocks noGrp="1"/>
+          </p:cNvSpPr>
+          <p:nvPr>
+            <p:ph type="sldNum" sz="quarter" idx="10"/>
+          </p:nvPr>
+        </p:nvSpPr>
+        <p:spPr/>
+        <p:txBody>
+          <a:bodyPr/>
+          <a:lstStyle/>
+          <a:p>
+            <a:fld id="{F7021451-1387-4CA6-816F-3879F97B5CBC}" type="slidenum">
+              <a:rPr lang="en-US"/>
+              <a:t>11</a:t>
             </a:fld>
             <a:endParaRPr lang="en-US"/>
           </a:p>
@@ -1215,7 +1304,7 @@
           <a:p>
             <a:r>
               <a:rPr lang="en-US" dirty="0"/>
-              <a:t>Lesson 1's logRunningCommand() asked the scheduler a question every tick and read entry zero off the answer — it worked because every command built so far either parks or loops until canceled, so there's always something running whenever you ask. That guarantee won't last: later lessons build commands that finish on their own, and Lesson 8 ships one that can finish the instant it's scheduled, before a poll ever gets a chance to see it run — asking at just the wrong moment means reading past the end of an empty list, not a stale answer. The fix isn't a smarter poll, it's not polling at all: the scheduler announces every SchedulerEvent it fires — scheduled, completed, canceled, interrupted, and a few more — and addEventListener reacts the instant one happens. The if line does two jobs at once: "event instanceof SchedulerEvent.Scheduled scheduled" asks whether this event is specifically a Scheduled event, and if so hands it back as a variable named scheduled, typed as that specific kind rather than the general SchedulerEvent — which is why the check has to come first, since only the specific kind has a .command() on it. The &amp;&amp; after it can use scheduled right away because Java only evaluates the rest of the line once the left side has already passed. scheduled.command().requires(module) matters because the same event stream fires for every mechanism on the robot, not just this one. Run it again and press the button: DriveModule/CurrentCommand still flips the same way as before — what changed is that it isn't asking anymore, it's told.</a:t>
+              <a:t>Lesson 1's logRunningCommand() asked the scheduler a question every tick and read entry zero off the answer — it worked because every command built so far either parks or loops until canceled, so there's always something running whenever you ask. That guarantee won't last: later lessons build commands that finish on their own, and Lesson 8 ships one that can finish the instant it's scheduled, before a poll ever gets a chance to see it run — asking at just the wrong moment means reading past the end of an empty list, not a stale answer. The fix isn't a smarter poll, it's not polling at all: the scheduler announces every SchedulerEvent it fires — scheduled, completed, canceled, interrupted, and a few more — and addEventListener reacts the instant one happens. Another method reference here, the same shorthand as this::logTelemetry back in section 4, just pointing at a different method. The if line does two jobs at once: "event instanceof SchedulerEvent.Scheduled scheduled" asks whether this event is specifically a Scheduled event, and if so hands it back as a variable named scheduled, typed as that specific kind rather than the general SchedulerEvent — which is why the check has to come first, since only the specific kind has a .command() on it. The &amp;&amp; after it can use scheduled right away because Java only evaluates the rest of the line once the left side has already passed. scheduled.command().requires(module) matters because the same event stream fires for every mechanism on the robot, not just this one. Run it again and press the button: DriveModule/CurrentCommand still flips the same way as before — what changed is that it isn't asking anymore, it's told.</a:t>
             </a:r>
             <a:endParaRPr lang="en-US" dirty="0"/>
           </a:p>
@@ -1303,7 +1392,7 @@
           <a:p>
             <a:r>
               <a:rPr lang="en-US" dirty="0"/>
-              <a:t>Logging the commanded speed is a refinement of the always-running rule from section 4: a value that only exists inside a command — like the command's own output — gets logged right where it's computed, not from a periodic callback. On a real robot, overlaying CommandedOutput against VelocityRotPerSec shows how the motor lags the command — the seed of understanding control, which pays off starting in Lesson 5. getPositionRotations() is worth calling out as exposing a reading method alongside command factories — that's fine, readings are safe to share, unlike commands. Renaming a dashboard key is a hands-on demonstration that the slash really is a folder path and the name really is the address — the old entry goes stale and a new folder appears in the tree. The SchedulerEvent.Completed exercise previews the vocabulary callout: Scheduled isn't the only kind of event.</a:t>
+              <a:t>logRunningCommand() is gone, and with it the only thing robotPeriodic() needs to do every tick is the scheduler tick itself — the command log takes care of itself now, reacting to events instead of being asked. Run it again and press the button: DriveModule/CurrentCommand on the dashboard still flips between "DriveModule[IDLE]" and "Drive At Speed", exactly like before. What changed is how it knows — the old version asked, every tick, and got lucky every time because nothing could finish between one ask and the next; the new version can't get unlucky, because it isn't asking anymore, it's told, the instant something happens, no matter how briefly "happens" lasts. Worth naming as a callout: Scheduled isn't the only kind of SchedulerEvent — there's a Completed for when a command finishes on its own, Canceled and Interrupted for the other two ways a command's life can end, and a couple more besides. Only one piece of that vocabulary got used here.</a:t>
             </a:r>
             <a:endParaRPr lang="en-US" dirty="0"/>
           </a:p>
@@ -1909,6 +1998,1105 @@
     <p:bg>
       <p:bgPr>
         <a:solidFill>
+          <a:srgbClr val="0B1F3A"/>
+        </a:solidFill>
+      </p:bgPr>
+    </p:bg>
+    <p:spTree>
+      <p:nvGrpSpPr>
+        <p:cNvPr id="1" name=""/>
+        <p:cNvGrpSpPr/>
+        <p:nvPr/>
+      </p:nvGrpSpPr>
+      <p:grpSpPr>
+        <a:xfrm>
+          <a:off x="0" y="0"/>
+          <a:ext cx="0" cy="0"/>
+          <a:chOff x="0" y="0"/>
+          <a:chExt cx="0" cy="0"/>
+        </a:xfrm>
+      </p:grpSpPr>
+      <p:sp>
+        <p:nvSpPr>
+          <p:cNvPr id="2" name="Shape 0"/>
+          <p:cNvSpPr/>
+          <p:nvPr/>
+        </p:nvSpPr>
+        <p:spPr>
+          <a:xfrm>
+            <a:off x="640080" y="457200"/>
+            <a:ext cx="566928" cy="566928"/>
+          </a:xfrm>
+          <a:prstGeom prst="ellipse">
+            <a:avLst/>
+          </a:prstGeom>
+          <a:solidFill>
+            <a:srgbClr val="FF5010"/>
+          </a:solidFill>
+          <a:ln/>
+        </p:spPr>
+      </p:sp>
+      <p:pic>
+        <p:nvPicPr>
+          <p:cNvPr id="3" name="Image 0" descr="/home/user/BasicRobotLessons/docs/presentations/v3/template/assets/icons/clipboardcheck_white.png">    </p:cNvPr>
+          <p:cNvPicPr>
+            <a:picLocks noChangeAspect="1"/>
+          </p:cNvPicPr>
+          <p:nvPr/>
+        </p:nvPicPr>
+        <p:blipFill>
+          <a:blip r:embed="rId1"/>
+          <a:stretch>
+            <a:fillRect/>
+          </a:stretch>
+        </p:blipFill>
+        <p:spPr>
+          <a:xfrm>
+            <a:off x="768096" y="585216"/>
+            <a:ext cx="310896" cy="310896"/>
+          </a:xfrm>
+          <a:prstGeom prst="rect">
+            <a:avLst/>
+          </a:prstGeom>
+        </p:spPr>
+      </p:pic>
+      <p:sp>
+        <p:nvSpPr>
+          <p:cNvPr id="4" name="Text 1"/>
+          <p:cNvSpPr/>
+          <p:nvPr/>
+        </p:nvSpPr>
+        <p:spPr>
+          <a:xfrm>
+            <a:off x="1389888" y="402336"/>
+            <a:ext cx="9144000" cy="365760"/>
+          </a:xfrm>
+          <a:prstGeom prst="rect">
+            <a:avLst/>
+          </a:prstGeom>
+          <a:noFill/>
+          <a:ln/>
+        </p:spPr>
+        <p:txBody>
+          <a:bodyPr wrap="square" lIns="0" tIns="0" rIns="0" bIns="0" rtlCol="0" anchor="ctr"/>
+          <a:lstStyle/>
+          <a:p>
+            <a:pPr indent="0" marL="0">
+              <a:buNone/>
+            </a:pPr>
+            <a:r>
+              <a:rPr lang="en-US" sz="2000" b="1" spc="100" kern="0" dirty="0">
+                <a:solidFill>
+                  <a:srgbClr val="1B9AAA"/>
+                </a:solidFill>
+                <a:latin typeface="Calibri" pitchFamily="34" charset="0"/>
+                <a:ea typeface="Calibri" pitchFamily="34" charset="-122"/>
+                <a:cs typeface="Calibri" pitchFamily="34" charset="-120"/>
+              </a:rPr>
+              <a:t>BEFORE YOU MOVE ON</a:t>
+            </a:r>
+            <a:endParaRPr lang="en-US" sz="2000" dirty="0"/>
+          </a:p>
+        </p:txBody>
+      </p:sp>
+      <p:sp>
+        <p:nvSpPr>
+          <p:cNvPr id="5" name="Text 2"/>
+          <p:cNvSpPr/>
+          <p:nvPr/>
+        </p:nvSpPr>
+        <p:spPr>
+          <a:xfrm>
+            <a:off x="1371600" y="749808"/>
+            <a:ext cx="9418320" cy="594360"/>
+          </a:xfrm>
+          <a:prstGeom prst="rect">
+            <a:avLst/>
+          </a:prstGeom>
+          <a:noFill/>
+          <a:ln/>
+        </p:spPr>
+        <p:txBody>
+          <a:bodyPr wrap="square" lIns="0" tIns="0" rIns="0" bIns="0" rtlCol="0" anchor="ctr"/>
+          <a:lstStyle/>
+          <a:p>
+            <a:pPr indent="0" marL="0">
+              <a:buNone/>
+            </a:pPr>
+            <a:r>
+              <a:rPr lang="en-US" sz="3000" b="1" dirty="0">
+                <a:solidFill>
+                  <a:srgbClr val="FFFFFF"/>
+                </a:solidFill>
+                <a:latin typeface="Cambria" pitchFamily="34" charset="0"/>
+                <a:ea typeface="Cambria" pitchFamily="34" charset="-122"/>
+                <a:cs typeface="Cambria" pitchFamily="34" charset="-120"/>
+              </a:rPr>
+              <a:t>Try it</a:t>
+            </a:r>
+            <a:endParaRPr lang="en-US" sz="3000" dirty="0"/>
+          </a:p>
+        </p:txBody>
+      </p:sp>
+      <p:sp>
+        <p:nvSpPr>
+          <p:cNvPr id="6" name="Shape 3"/>
+          <p:cNvSpPr/>
+          <p:nvPr/>
+        </p:nvSpPr>
+        <p:spPr>
+          <a:xfrm>
+            <a:off x="640080" y="1463040"/>
+            <a:ext cx="5303520" cy="2286000"/>
+          </a:xfrm>
+          <a:prstGeom prst="roundRect">
+            <a:avLst>
+              <a:gd name="adj" fmla="val 4800"/>
+            </a:avLst>
+          </a:prstGeom>
+          <a:solidFill>
+            <a:srgbClr val="132A4C"/>
+          </a:solidFill>
+          <a:ln/>
+        </p:spPr>
+      </p:sp>
+      <p:sp>
+        <p:nvSpPr>
+          <p:cNvPr id="7" name="Shape 4"/>
+          <p:cNvSpPr/>
+          <p:nvPr/>
+        </p:nvSpPr>
+        <p:spPr>
+          <a:xfrm>
+            <a:off x="960120" y="1691640"/>
+            <a:ext cx="457200" cy="457200"/>
+          </a:xfrm>
+          <a:prstGeom prst="ellipse">
+            <a:avLst/>
+          </a:prstGeom>
+          <a:solidFill>
+            <a:srgbClr val="1B9AAA"/>
+          </a:solidFill>
+          <a:ln/>
+        </p:spPr>
+      </p:sp>
+      <p:sp>
+        <p:nvSpPr>
+          <p:cNvPr id="8" name="Text 5"/>
+          <p:cNvSpPr/>
+          <p:nvPr/>
+        </p:nvSpPr>
+        <p:spPr>
+          <a:xfrm>
+            <a:off x="960120" y="1691640"/>
+            <a:ext cx="457200" cy="457200"/>
+          </a:xfrm>
+          <a:prstGeom prst="rect">
+            <a:avLst/>
+          </a:prstGeom>
+          <a:noFill/>
+          <a:ln/>
+        </p:spPr>
+        <p:txBody>
+          <a:bodyPr wrap="square" lIns="0" tIns="0" rIns="0" bIns="0" rtlCol="0" anchor="ctr"/>
+          <a:lstStyle/>
+          <a:p>
+            <a:pPr algn="ctr" indent="0" marL="0">
+              <a:buNone/>
+            </a:pPr>
+            <a:r>
+              <a:rPr lang="en-US" sz="2200" b="1" dirty="0">
+                <a:solidFill>
+                  <a:srgbClr val="FFFFFF"/>
+                </a:solidFill>
+                <a:latin typeface="Cambria" pitchFamily="34" charset="0"/>
+                <a:ea typeface="Cambria" pitchFamily="34" charset="-122"/>
+                <a:cs typeface="Cambria" pitchFamily="34" charset="-120"/>
+              </a:rPr>
+              <a:t>1</a:t>
+            </a:r>
+            <a:endParaRPr lang="en-US" sz="2200" dirty="0"/>
+          </a:p>
+        </p:txBody>
+      </p:sp>
+      <p:sp>
+        <p:nvSpPr>
+          <p:cNvPr id="9" name="Text 6"/>
+          <p:cNvSpPr/>
+          <p:nvPr/>
+        </p:nvSpPr>
+        <p:spPr>
+          <a:xfrm>
+            <a:off x="1600200" y="1691640"/>
+            <a:ext cx="2606040" cy="457200"/>
+          </a:xfrm>
+          <a:prstGeom prst="rect">
+            <a:avLst/>
+          </a:prstGeom>
+          <a:noFill/>
+          <a:ln/>
+        </p:spPr>
+        <p:txBody>
+          <a:bodyPr wrap="square" lIns="0" tIns="0" rIns="0" bIns="0" rtlCol="0" anchor="ctr"/>
+          <a:lstStyle/>
+          <a:p>
+            <a:pPr indent="0" marL="0">
+              <a:lnSpc>
+                <a:spcPct val="110000"/>
+              </a:lnSpc>
+              <a:buNone/>
+            </a:pPr>
+            <a:r>
+              <a:rPr lang="en-US" sz="2000" b="1" dirty="0">
+                <a:solidFill>
+                  <a:srgbClr val="FFFFFF"/>
+                </a:solidFill>
+                <a:latin typeface="Cambria" pitchFamily="34" charset="0"/>
+                <a:ea typeface="Cambria" pitchFamily="34" charset="-122"/>
+                <a:cs typeface="Cambria" pitchFamily="34" charset="-120"/>
+              </a:rPr>
+              <a:t>Log the commanded speed</a:t>
+            </a:r>
+            <a:endParaRPr lang="en-US" sz="2000" dirty="0"/>
+          </a:p>
+        </p:txBody>
+      </p:sp>
+      <p:sp>
+        <p:nvSpPr>
+          <p:cNvPr id="10" name="Shape 7"/>
+          <p:cNvSpPr/>
+          <p:nvPr/>
+        </p:nvSpPr>
+        <p:spPr>
+          <a:xfrm>
+            <a:off x="4206240" y="1773936"/>
+            <a:ext cx="1417320" cy="292608"/>
+          </a:xfrm>
+          <a:prstGeom prst="roundRect">
+            <a:avLst>
+              <a:gd name="adj" fmla="val 18750"/>
+            </a:avLst>
+          </a:prstGeom>
+          <a:solidFill>
+            <a:srgbClr val="FF5010"/>
+          </a:solidFill>
+          <a:ln/>
+        </p:spPr>
+      </p:sp>
+      <p:sp>
+        <p:nvSpPr>
+          <p:cNvPr id="11" name="Text 8"/>
+          <p:cNvSpPr/>
+          <p:nvPr/>
+        </p:nvSpPr>
+        <p:spPr>
+          <a:xfrm>
+            <a:off x="4206240" y="1773936"/>
+            <a:ext cx="1417320" cy="292608"/>
+          </a:xfrm>
+          <a:prstGeom prst="rect">
+            <a:avLst/>
+          </a:prstGeom>
+          <a:noFill/>
+          <a:ln/>
+        </p:spPr>
+        <p:txBody>
+          <a:bodyPr wrap="square" lIns="0" tIns="0" rIns="0" bIns="0" rtlCol="0" anchor="ctr"/>
+          <a:lstStyle/>
+          <a:p>
+            <a:pPr algn="ctr" indent="0" marL="0">
+              <a:buNone/>
+            </a:pPr>
+            <a:r>
+              <a:rPr lang="en-US" sz="1200" b="1" spc="50" kern="0" dirty="0">
+                <a:solidFill>
+                  <a:srgbClr val="0B1F3A"/>
+                </a:solidFill>
+                <a:latin typeface="Calibri" pitchFamily="34" charset="0"/>
+                <a:ea typeface="Calibri" pitchFamily="34" charset="-122"/>
+                <a:cs typeface="Calibri" pitchFamily="34" charset="-120"/>
+              </a:rPr>
+              <a:t>WRITE CODE</a:t>
+            </a:r>
+            <a:endParaRPr lang="en-US" sz="1200" dirty="0"/>
+          </a:p>
+        </p:txBody>
+      </p:sp>
+      <p:sp>
+        <p:nvSpPr>
+          <p:cNvPr id="12" name="Text 9"/>
+          <p:cNvSpPr/>
+          <p:nvPr/>
+        </p:nvSpPr>
+        <p:spPr>
+          <a:xfrm>
+            <a:off x="960120" y="2286000"/>
+            <a:ext cx="4663440" cy="1188720"/>
+          </a:xfrm>
+          <a:prstGeom prst="rect">
+            <a:avLst/>
+          </a:prstGeom>
+          <a:noFill/>
+          <a:ln/>
+        </p:spPr>
+        <p:txBody>
+          <a:bodyPr wrap="square" lIns="0" tIns="0" rIns="0" bIns="0" rtlCol="0" anchor="t"/>
+          <a:lstStyle/>
+          <a:p>
+            <a:pPr indent="0" marL="0">
+              <a:lnSpc>
+                <a:spcPct val="125000"/>
+              </a:lnSpc>
+              <a:buNone/>
+            </a:pPr>
+            <a:r>
+              <a:rPr lang="en-US" sz="2000" dirty="0">
+                <a:solidFill>
+                  <a:srgbClr val="CADCE8"/>
+                </a:solidFill>
+                <a:latin typeface="Calibri" pitchFamily="34" charset="0"/>
+                <a:ea typeface="Calibri" pitchFamily="34" charset="-122"/>
+                <a:cs typeface="Calibri" pitchFamily="34" charset="-120"/>
+              </a:rPr>
+              <a:t>Inside driveWithJoystick's loop, log CommandedOutput right where it's computed.</a:t>
+            </a:r>
+            <a:endParaRPr lang="en-US" sz="2000" dirty="0"/>
+          </a:p>
+        </p:txBody>
+      </p:sp>
+      <p:sp>
+        <p:nvSpPr>
+          <p:cNvPr id="13" name="Shape 10"/>
+          <p:cNvSpPr/>
+          <p:nvPr/>
+        </p:nvSpPr>
+        <p:spPr>
+          <a:xfrm>
+            <a:off x="6217920" y="1463040"/>
+            <a:ext cx="5303520" cy="2286000"/>
+          </a:xfrm>
+          <a:prstGeom prst="roundRect">
+            <a:avLst>
+              <a:gd name="adj" fmla="val 4800"/>
+            </a:avLst>
+          </a:prstGeom>
+          <a:solidFill>
+            <a:srgbClr val="132A4C"/>
+          </a:solidFill>
+          <a:ln/>
+        </p:spPr>
+      </p:sp>
+      <p:sp>
+        <p:nvSpPr>
+          <p:cNvPr id="14" name="Shape 11"/>
+          <p:cNvSpPr/>
+          <p:nvPr/>
+        </p:nvSpPr>
+        <p:spPr>
+          <a:xfrm>
+            <a:off x="6537960" y="1691640"/>
+            <a:ext cx="457200" cy="457200"/>
+          </a:xfrm>
+          <a:prstGeom prst="ellipse">
+            <a:avLst/>
+          </a:prstGeom>
+          <a:solidFill>
+            <a:srgbClr val="1B9AAA"/>
+          </a:solidFill>
+          <a:ln/>
+        </p:spPr>
+      </p:sp>
+      <p:sp>
+        <p:nvSpPr>
+          <p:cNvPr id="15" name="Text 12"/>
+          <p:cNvSpPr/>
+          <p:nvPr/>
+        </p:nvSpPr>
+        <p:spPr>
+          <a:xfrm>
+            <a:off x="6537960" y="1691640"/>
+            <a:ext cx="457200" cy="457200"/>
+          </a:xfrm>
+          <a:prstGeom prst="rect">
+            <a:avLst/>
+          </a:prstGeom>
+          <a:noFill/>
+          <a:ln/>
+        </p:spPr>
+        <p:txBody>
+          <a:bodyPr wrap="square" lIns="0" tIns="0" rIns="0" bIns="0" rtlCol="0" anchor="ctr"/>
+          <a:lstStyle/>
+          <a:p>
+            <a:pPr algn="ctr" indent="0" marL="0">
+              <a:buNone/>
+            </a:pPr>
+            <a:r>
+              <a:rPr lang="en-US" sz="2200" b="1" dirty="0">
+                <a:solidFill>
+                  <a:srgbClr val="FFFFFF"/>
+                </a:solidFill>
+                <a:latin typeface="Cambria" pitchFamily="34" charset="0"/>
+                <a:ea typeface="Cambria" pitchFamily="34" charset="-122"/>
+                <a:cs typeface="Cambria" pitchFamily="34" charset="-120"/>
+              </a:rPr>
+              <a:t>2</a:t>
+            </a:r>
+            <a:endParaRPr lang="en-US" sz="2200" dirty="0"/>
+          </a:p>
+        </p:txBody>
+      </p:sp>
+      <p:sp>
+        <p:nvSpPr>
+          <p:cNvPr id="16" name="Text 13"/>
+          <p:cNvSpPr/>
+          <p:nvPr/>
+        </p:nvSpPr>
+        <p:spPr>
+          <a:xfrm>
+            <a:off x="7178040" y="1691640"/>
+            <a:ext cx="2606040" cy="457200"/>
+          </a:xfrm>
+          <a:prstGeom prst="rect">
+            <a:avLst/>
+          </a:prstGeom>
+          <a:noFill/>
+          <a:ln/>
+        </p:spPr>
+        <p:txBody>
+          <a:bodyPr wrap="square" lIns="0" tIns="0" rIns="0" bIns="0" rtlCol="0" anchor="ctr"/>
+          <a:lstStyle/>
+          <a:p>
+            <a:pPr indent="0" marL="0">
+              <a:lnSpc>
+                <a:spcPct val="110000"/>
+              </a:lnSpc>
+              <a:buNone/>
+            </a:pPr>
+            <a:r>
+              <a:rPr lang="en-US" sz="2000" b="1" dirty="0">
+                <a:solidFill>
+                  <a:srgbClr val="FFFFFF"/>
+                </a:solidFill>
+                <a:latin typeface="Cambria" pitchFamily="34" charset="0"/>
+                <a:ea typeface="Cambria" pitchFamily="34" charset="-122"/>
+                <a:cs typeface="Cambria" pitchFamily="34" charset="-120"/>
+              </a:rPr>
+              <a:t>Add getPositionRotations()</a:t>
+            </a:r>
+            <a:endParaRPr lang="en-US" sz="2000" dirty="0"/>
+          </a:p>
+        </p:txBody>
+      </p:sp>
+      <p:sp>
+        <p:nvSpPr>
+          <p:cNvPr id="17" name="Shape 14"/>
+          <p:cNvSpPr/>
+          <p:nvPr/>
+        </p:nvSpPr>
+        <p:spPr>
+          <a:xfrm>
+            <a:off x="9784080" y="1773936"/>
+            <a:ext cx="1417320" cy="292608"/>
+          </a:xfrm>
+          <a:prstGeom prst="roundRect">
+            <a:avLst>
+              <a:gd name="adj" fmla="val 18750"/>
+            </a:avLst>
+          </a:prstGeom>
+          <a:solidFill>
+            <a:srgbClr val="FF5010"/>
+          </a:solidFill>
+          <a:ln/>
+        </p:spPr>
+      </p:sp>
+      <p:sp>
+        <p:nvSpPr>
+          <p:cNvPr id="18" name="Text 15"/>
+          <p:cNvSpPr/>
+          <p:nvPr/>
+        </p:nvSpPr>
+        <p:spPr>
+          <a:xfrm>
+            <a:off x="9784080" y="1773936"/>
+            <a:ext cx="1417320" cy="292608"/>
+          </a:xfrm>
+          <a:prstGeom prst="rect">
+            <a:avLst/>
+          </a:prstGeom>
+          <a:noFill/>
+          <a:ln/>
+        </p:spPr>
+        <p:txBody>
+          <a:bodyPr wrap="square" lIns="0" tIns="0" rIns="0" bIns="0" rtlCol="0" anchor="ctr"/>
+          <a:lstStyle/>
+          <a:p>
+            <a:pPr algn="ctr" indent="0" marL="0">
+              <a:buNone/>
+            </a:pPr>
+            <a:r>
+              <a:rPr lang="en-US" sz="1200" b="1" spc="50" kern="0" dirty="0">
+                <a:solidFill>
+                  <a:srgbClr val="0B1F3A"/>
+                </a:solidFill>
+                <a:latin typeface="Calibri" pitchFamily="34" charset="0"/>
+                <a:ea typeface="Calibri" pitchFamily="34" charset="-122"/>
+                <a:cs typeface="Calibri" pitchFamily="34" charset="-120"/>
+              </a:rPr>
+              <a:t>WRITE CODE</a:t>
+            </a:r>
+            <a:endParaRPr lang="en-US" sz="1200" dirty="0"/>
+          </a:p>
+        </p:txBody>
+      </p:sp>
+      <p:sp>
+        <p:nvSpPr>
+          <p:cNvPr id="19" name="Text 16"/>
+          <p:cNvSpPr/>
+          <p:nvPr/>
+        </p:nvSpPr>
+        <p:spPr>
+          <a:xfrm>
+            <a:off x="6537960" y="2286000"/>
+            <a:ext cx="4663440" cy="1188720"/>
+          </a:xfrm>
+          <a:prstGeom prst="rect">
+            <a:avLst/>
+          </a:prstGeom>
+          <a:noFill/>
+          <a:ln/>
+        </p:spPr>
+        <p:txBody>
+          <a:bodyPr wrap="square" lIns="0" tIns="0" rIns="0" bIns="0" rtlCol="0" anchor="t"/>
+          <a:lstStyle/>
+          <a:p>
+            <a:pPr indent="0" marL="0">
+              <a:lnSpc>
+                <a:spcPct val="125000"/>
+              </a:lnSpc>
+              <a:buNone/>
+            </a:pPr>
+            <a:r>
+              <a:rPr lang="en-US" sz="2000" dirty="0">
+                <a:solidFill>
+                  <a:srgbClr val="CADCE8"/>
+                </a:solidFill>
+                <a:latin typeface="Calibri" pitchFamily="34" charset="0"/>
+                <a:ea typeface="Calibri" pitchFamily="34" charset="-122"/>
+                <a:cs typeface="Calibri" pitchFamily="34" charset="-120"/>
+              </a:rPr>
+              <a:t>A reading method returning position as a double — safe to share, unlike a command.</a:t>
+            </a:r>
+            <a:endParaRPr lang="en-US" sz="2000" dirty="0"/>
+          </a:p>
+        </p:txBody>
+      </p:sp>
+      <p:sp>
+        <p:nvSpPr>
+          <p:cNvPr id="20" name="Shape 17"/>
+          <p:cNvSpPr/>
+          <p:nvPr/>
+        </p:nvSpPr>
+        <p:spPr>
+          <a:xfrm>
+            <a:off x="640080" y="4023360"/>
+            <a:ext cx="5303520" cy="2286000"/>
+          </a:xfrm>
+          <a:prstGeom prst="roundRect">
+            <a:avLst>
+              <a:gd name="adj" fmla="val 4800"/>
+            </a:avLst>
+          </a:prstGeom>
+          <a:solidFill>
+            <a:srgbClr val="132A4C"/>
+          </a:solidFill>
+          <a:ln/>
+        </p:spPr>
+      </p:sp>
+      <p:sp>
+        <p:nvSpPr>
+          <p:cNvPr id="21" name="Shape 18"/>
+          <p:cNvSpPr/>
+          <p:nvPr/>
+        </p:nvSpPr>
+        <p:spPr>
+          <a:xfrm>
+            <a:off x="960120" y="4251960"/>
+            <a:ext cx="457200" cy="457200"/>
+          </a:xfrm>
+          <a:prstGeom prst="ellipse">
+            <a:avLst/>
+          </a:prstGeom>
+          <a:solidFill>
+            <a:srgbClr val="1B9AAA"/>
+          </a:solidFill>
+          <a:ln/>
+        </p:spPr>
+      </p:sp>
+      <p:sp>
+        <p:nvSpPr>
+          <p:cNvPr id="22" name="Text 19"/>
+          <p:cNvSpPr/>
+          <p:nvPr/>
+        </p:nvSpPr>
+        <p:spPr>
+          <a:xfrm>
+            <a:off x="960120" y="4251960"/>
+            <a:ext cx="457200" cy="457200"/>
+          </a:xfrm>
+          <a:prstGeom prst="rect">
+            <a:avLst/>
+          </a:prstGeom>
+          <a:noFill/>
+          <a:ln/>
+        </p:spPr>
+        <p:txBody>
+          <a:bodyPr wrap="square" lIns="0" tIns="0" rIns="0" bIns="0" rtlCol="0" anchor="ctr"/>
+          <a:lstStyle/>
+          <a:p>
+            <a:pPr algn="ctr" indent="0" marL="0">
+              <a:buNone/>
+            </a:pPr>
+            <a:r>
+              <a:rPr lang="en-US" sz="2200" b="1" dirty="0">
+                <a:solidFill>
+                  <a:srgbClr val="FFFFFF"/>
+                </a:solidFill>
+                <a:latin typeface="Cambria" pitchFamily="34" charset="0"/>
+                <a:ea typeface="Cambria" pitchFamily="34" charset="-122"/>
+                <a:cs typeface="Cambria" pitchFamily="34" charset="-120"/>
+              </a:rPr>
+              <a:t>3</a:t>
+            </a:r>
+            <a:endParaRPr lang="en-US" sz="2200" dirty="0"/>
+          </a:p>
+        </p:txBody>
+      </p:sp>
+      <p:sp>
+        <p:nvSpPr>
+          <p:cNvPr id="23" name="Text 20"/>
+          <p:cNvSpPr/>
+          <p:nvPr/>
+        </p:nvSpPr>
+        <p:spPr>
+          <a:xfrm>
+            <a:off x="1600200" y="4251960"/>
+            <a:ext cx="4023360" cy="457200"/>
+          </a:xfrm>
+          <a:prstGeom prst="rect">
+            <a:avLst/>
+          </a:prstGeom>
+          <a:noFill/>
+          <a:ln/>
+        </p:spPr>
+        <p:txBody>
+          <a:bodyPr wrap="square" lIns="0" tIns="0" rIns="0" bIns="0" rtlCol="0" anchor="ctr"/>
+          <a:lstStyle/>
+          <a:p>
+            <a:pPr indent="0" marL="0">
+              <a:lnSpc>
+                <a:spcPct val="110000"/>
+              </a:lnSpc>
+              <a:buNone/>
+            </a:pPr>
+            <a:r>
+              <a:rPr lang="en-US" sz="2000" b="1" dirty="0">
+                <a:solidFill>
+                  <a:srgbClr val="FFFFFF"/>
+                </a:solidFill>
+                <a:latin typeface="Cambria" pitchFamily="34" charset="0"/>
+                <a:ea typeface="Cambria" pitchFamily="34" charset="-122"/>
+                <a:cs typeface="Cambria" pitchFamily="34" charset="-120"/>
+              </a:rPr>
+              <a:t>Rename a dashboard key</a:t>
+            </a:r>
+            <a:endParaRPr lang="en-US" sz="2000" dirty="0"/>
+          </a:p>
+        </p:txBody>
+      </p:sp>
+      <p:sp>
+        <p:nvSpPr>
+          <p:cNvPr id="24" name="Text 21"/>
+          <p:cNvSpPr/>
+          <p:nvPr/>
+        </p:nvSpPr>
+        <p:spPr>
+          <a:xfrm>
+            <a:off x="960120" y="4846320"/>
+            <a:ext cx="4663440" cy="1188720"/>
+          </a:xfrm>
+          <a:prstGeom prst="rect">
+            <a:avLst/>
+          </a:prstGeom>
+          <a:noFill/>
+          <a:ln/>
+        </p:spPr>
+        <p:txBody>
+          <a:bodyPr wrap="square" lIns="0" tIns="0" rIns="0" bIns="0" rtlCol="0" anchor="t"/>
+          <a:lstStyle/>
+          <a:p>
+            <a:pPr indent="0" marL="0">
+              <a:lnSpc>
+                <a:spcPct val="125000"/>
+              </a:lnSpc>
+              <a:buNone/>
+            </a:pPr>
+            <a:r>
+              <a:rPr lang="en-US" sz="2000" dirty="0">
+                <a:solidFill>
+                  <a:srgbClr val="CADCE8"/>
+                </a:solidFill>
+                <a:latin typeface="Calibri" pitchFamily="34" charset="0"/>
+                <a:ea typeface="Calibri" pitchFamily="34" charset="-122"/>
+                <a:cs typeface="Calibri" pitchFamily="34" charset="-120"/>
+              </a:rPr>
+              <a:t>Swap "DriveModule/" for "Elevator/", rebuild, and watch a new folder appear in the tree.</a:t>
+            </a:r>
+            <a:endParaRPr lang="en-US" sz="2000" dirty="0"/>
+          </a:p>
+        </p:txBody>
+      </p:sp>
+      <p:sp>
+        <p:nvSpPr>
+          <p:cNvPr id="25" name="Shape 22"/>
+          <p:cNvSpPr/>
+          <p:nvPr/>
+        </p:nvSpPr>
+        <p:spPr>
+          <a:xfrm>
+            <a:off x="6217920" y="4023360"/>
+            <a:ext cx="5303520" cy="2286000"/>
+          </a:xfrm>
+          <a:prstGeom prst="roundRect">
+            <a:avLst>
+              <a:gd name="adj" fmla="val 4800"/>
+            </a:avLst>
+          </a:prstGeom>
+          <a:solidFill>
+            <a:srgbClr val="132A4C"/>
+          </a:solidFill>
+          <a:ln/>
+        </p:spPr>
+      </p:sp>
+      <p:sp>
+        <p:nvSpPr>
+          <p:cNvPr id="26" name="Shape 23"/>
+          <p:cNvSpPr/>
+          <p:nvPr/>
+        </p:nvSpPr>
+        <p:spPr>
+          <a:xfrm>
+            <a:off x="6537960" y="4251960"/>
+            <a:ext cx="457200" cy="457200"/>
+          </a:xfrm>
+          <a:prstGeom prst="ellipse">
+            <a:avLst/>
+          </a:prstGeom>
+          <a:solidFill>
+            <a:srgbClr val="1B9AAA"/>
+          </a:solidFill>
+          <a:ln/>
+        </p:spPr>
+      </p:sp>
+      <p:sp>
+        <p:nvSpPr>
+          <p:cNvPr id="27" name="Text 24"/>
+          <p:cNvSpPr/>
+          <p:nvPr/>
+        </p:nvSpPr>
+        <p:spPr>
+          <a:xfrm>
+            <a:off x="6537960" y="4251960"/>
+            <a:ext cx="457200" cy="457200"/>
+          </a:xfrm>
+          <a:prstGeom prst="rect">
+            <a:avLst/>
+          </a:prstGeom>
+          <a:noFill/>
+          <a:ln/>
+        </p:spPr>
+        <p:txBody>
+          <a:bodyPr wrap="square" lIns="0" tIns="0" rIns="0" bIns="0" rtlCol="0" anchor="ctr"/>
+          <a:lstStyle/>
+          <a:p>
+            <a:pPr algn="ctr" indent="0" marL="0">
+              <a:buNone/>
+            </a:pPr>
+            <a:r>
+              <a:rPr lang="en-US" sz="2200" b="1" dirty="0">
+                <a:solidFill>
+                  <a:srgbClr val="FFFFFF"/>
+                </a:solidFill>
+                <a:latin typeface="Cambria" pitchFamily="34" charset="0"/>
+                <a:ea typeface="Cambria" pitchFamily="34" charset="-122"/>
+                <a:cs typeface="Cambria" pitchFamily="34" charset="-120"/>
+              </a:rPr>
+              <a:t>4</a:t>
+            </a:r>
+            <a:endParaRPr lang="en-US" sz="2200" dirty="0"/>
+          </a:p>
+        </p:txBody>
+      </p:sp>
+      <p:sp>
+        <p:nvSpPr>
+          <p:cNvPr id="28" name="Text 25"/>
+          <p:cNvSpPr/>
+          <p:nvPr/>
+        </p:nvSpPr>
+        <p:spPr>
+          <a:xfrm>
+            <a:off x="7178040" y="4251960"/>
+            <a:ext cx="2606040" cy="457200"/>
+          </a:xfrm>
+          <a:prstGeom prst="rect">
+            <a:avLst/>
+          </a:prstGeom>
+          <a:noFill/>
+          <a:ln/>
+        </p:spPr>
+        <p:txBody>
+          <a:bodyPr wrap="square" lIns="0" tIns="0" rIns="0" bIns="0" rtlCol="0" anchor="ctr"/>
+          <a:lstStyle/>
+          <a:p>
+            <a:pPr indent="0" marL="0">
+              <a:lnSpc>
+                <a:spcPct val="110000"/>
+              </a:lnSpc>
+              <a:buNone/>
+            </a:pPr>
+            <a:r>
+              <a:rPr lang="en-US" sz="2000" b="1" dirty="0">
+                <a:solidFill>
+                  <a:srgbClr val="FFFFFF"/>
+                </a:solidFill>
+                <a:latin typeface="Cambria" pitchFamily="34" charset="0"/>
+                <a:ea typeface="Cambria" pitchFamily="34" charset="-122"/>
+                <a:cs typeface="Cambria" pitchFamily="34" charset="-120"/>
+              </a:rPr>
+              <a:t>Log when a command completes</a:t>
+            </a:r>
+            <a:endParaRPr lang="en-US" sz="2000" dirty="0"/>
+          </a:p>
+        </p:txBody>
+      </p:sp>
+      <p:sp>
+        <p:nvSpPr>
+          <p:cNvPr id="29" name="Shape 26"/>
+          <p:cNvSpPr/>
+          <p:nvPr/>
+        </p:nvSpPr>
+        <p:spPr>
+          <a:xfrm>
+            <a:off x="9784080" y="4334256"/>
+            <a:ext cx="1417320" cy="292608"/>
+          </a:xfrm>
+          <a:prstGeom prst="roundRect">
+            <a:avLst>
+              <a:gd name="adj" fmla="val 18750"/>
+            </a:avLst>
+          </a:prstGeom>
+          <a:solidFill>
+            <a:srgbClr val="FF5010"/>
+          </a:solidFill>
+          <a:ln/>
+        </p:spPr>
+      </p:sp>
+      <p:sp>
+        <p:nvSpPr>
+          <p:cNvPr id="30" name="Text 27"/>
+          <p:cNvSpPr/>
+          <p:nvPr/>
+        </p:nvSpPr>
+        <p:spPr>
+          <a:xfrm>
+            <a:off x="9784080" y="4334256"/>
+            <a:ext cx="1417320" cy="292608"/>
+          </a:xfrm>
+          <a:prstGeom prst="rect">
+            <a:avLst/>
+          </a:prstGeom>
+          <a:noFill/>
+          <a:ln/>
+        </p:spPr>
+        <p:txBody>
+          <a:bodyPr wrap="square" lIns="0" tIns="0" rIns="0" bIns="0" rtlCol="0" anchor="ctr"/>
+          <a:lstStyle/>
+          <a:p>
+            <a:pPr algn="ctr" indent="0" marL="0">
+              <a:buNone/>
+            </a:pPr>
+            <a:r>
+              <a:rPr lang="en-US" sz="1200" b="1" spc="50" kern="0" dirty="0">
+                <a:solidFill>
+                  <a:srgbClr val="0B1F3A"/>
+                </a:solidFill>
+                <a:latin typeface="Calibri" pitchFamily="34" charset="0"/>
+                <a:ea typeface="Calibri" pitchFamily="34" charset="-122"/>
+                <a:cs typeface="Calibri" pitchFamily="34" charset="-120"/>
+              </a:rPr>
+              <a:t>WRITE CODE</a:t>
+            </a:r>
+            <a:endParaRPr lang="en-US" sz="1200" dirty="0"/>
+          </a:p>
+        </p:txBody>
+      </p:sp>
+      <p:sp>
+        <p:nvSpPr>
+          <p:cNvPr id="31" name="Text 28"/>
+          <p:cNvSpPr/>
+          <p:nvPr/>
+        </p:nvSpPr>
+        <p:spPr>
+          <a:xfrm>
+            <a:off x="6537960" y="4846320"/>
+            <a:ext cx="4663440" cy="1188720"/>
+          </a:xfrm>
+          <a:prstGeom prst="rect">
+            <a:avLst/>
+          </a:prstGeom>
+          <a:noFill/>
+          <a:ln/>
+        </p:spPr>
+        <p:txBody>
+          <a:bodyPr wrap="square" lIns="0" tIns="0" rIns="0" bIns="0" rtlCol="0" anchor="t"/>
+          <a:lstStyle/>
+          <a:p>
+            <a:pPr indent="0" marL="0">
+              <a:lnSpc>
+                <a:spcPct val="125000"/>
+              </a:lnSpc>
+              <a:buNone/>
+            </a:pPr>
+            <a:r>
+              <a:rPr lang="en-US" sz="2000" dirty="0">
+                <a:solidFill>
+                  <a:srgbClr val="CADCE8"/>
+                </a:solidFill>
+                <a:latin typeface="Calibri" pitchFamily="34" charset="0"/>
+                <a:ea typeface="Calibri" pitchFamily="34" charset="-122"/>
+                <a:cs typeface="Calibri" pitchFamily="34" charset="-120"/>
+              </a:rPr>
+              <a:t>Handle SchedulerEvent.Completed and write LastCompletedCommand.</a:t>
+            </a:r>
+            <a:endParaRPr lang="en-US" sz="2000" dirty="0"/>
+          </a:p>
+        </p:txBody>
+      </p:sp>
+      <p:sp>
+        <p:nvSpPr>
+          <p:cNvPr id="32" name="Text 29"/>
+          <p:cNvSpPr/>
+          <p:nvPr/>
+        </p:nvSpPr>
+        <p:spPr>
+          <a:xfrm>
+            <a:off x="640080" y="6446520"/>
+            <a:ext cx="8229600" cy="365760"/>
+          </a:xfrm>
+          <a:prstGeom prst="rect">
+            <a:avLst/>
+          </a:prstGeom>
+          <a:noFill/>
+          <a:ln/>
+        </p:spPr>
+        <p:txBody>
+          <a:bodyPr wrap="square" lIns="0" tIns="0" rIns="0" bIns="0" rtlCol="0" anchor="ctr"/>
+          <a:lstStyle/>
+          <a:p>
+            <a:pPr indent="0" marL="0">
+              <a:buNone/>
+            </a:pPr>
+            <a:r>
+              <a:rPr lang="en-US" sz="2000" spc="100" kern="0" dirty="0">
+                <a:solidFill>
+                  <a:srgbClr val="7A93B8"/>
+                </a:solidFill>
+                <a:latin typeface="Calibri" pitchFamily="34" charset="0"/>
+                <a:ea typeface="Calibri" pitchFamily="34" charset="-122"/>
+                <a:cs typeface="Calibri" pitchFamily="34" charset="-120"/>
+              </a:rPr>
+              <a:t>LEARN JAVA + ROBOT PROGRAMMING · TELEMETRY</a:t>
+            </a:r>
+            <a:endParaRPr lang="en-US" sz="2000" dirty="0"/>
+          </a:p>
+        </p:txBody>
+      </p:sp>
+      <p:sp>
+        <p:nvSpPr>
+          <p:cNvPr id="33" name="Text 30"/>
+          <p:cNvSpPr/>
+          <p:nvPr/>
+        </p:nvSpPr>
+        <p:spPr>
+          <a:xfrm>
+            <a:off x="11002975" y="6446520"/>
+            <a:ext cx="548640" cy="365760"/>
+          </a:xfrm>
+          <a:prstGeom prst="rect">
+            <a:avLst/>
+          </a:prstGeom>
+          <a:noFill/>
+          <a:ln/>
+        </p:spPr>
+        <p:txBody>
+          <a:bodyPr wrap="square" lIns="0" tIns="0" rIns="0" bIns="0" rtlCol="0" anchor="ctr"/>
+          <a:lstStyle/>
+          <a:p>
+            <a:pPr algn="r" indent="0" marL="0">
+              <a:buNone/>
+            </a:pPr>
+            <a:r>
+              <a:rPr lang="en-US" sz="2000" dirty="0">
+                <a:solidFill>
+                  <a:srgbClr val="7A93B8"/>
+                </a:solidFill>
+                <a:latin typeface="Calibri" pitchFamily="34" charset="0"/>
+                <a:ea typeface="Calibri" pitchFamily="34" charset="-122"/>
+                <a:cs typeface="Calibri" pitchFamily="34" charset="-120"/>
+              </a:rPr>
+              <a:t>10</a:t>
+            </a:r>
+            <a:endParaRPr lang="en-US" sz="2000" dirty="0"/>
+          </a:p>
+        </p:txBody>
+      </p:sp>
+      <p:pic>
+        <p:nvPicPr>
+          <p:cNvPr id="34" name="Image 1" descr="/home/user/BasicRobotLessons/docs/presentations/v3/template/assets/logo/team5010-logo-onnavy.png">    </p:cNvPr>
+          <p:cNvPicPr>
+            <a:picLocks noChangeAspect="1"/>
+          </p:cNvPicPr>
+          <p:nvPr/>
+        </p:nvPicPr>
+        <p:blipFill>
+          <a:blip r:embed="rId2"/>
+          <a:stretch>
+            <a:fillRect/>
+          </a:stretch>
+        </p:blipFill>
+        <p:spPr>
+          <a:xfrm>
+            <a:off x="10957255" y="164592"/>
+            <a:ext cx="777240" cy="605859"/>
+          </a:xfrm>
+          <a:prstGeom prst="rect">
+            <a:avLst/>
+          </a:prstGeom>
+        </p:spPr>
+      </p:pic>
+    </p:spTree>
+  </p:cSld>
+  <p:clrMapOvr>
+    <a:masterClrMapping/>
+  </p:clrMapOvr>
+</p:sld>
+</file>
+
+<file path=ppt/slides/slide11.xml><?xml version="1.0" encoding="utf-8"?>
+<p:sld xmlns:a="http://schemas.openxmlformats.org/drawingml/2006/main" xmlns:r="http://schemas.openxmlformats.org/officeDocument/2006/relationships" xmlns:p="http://schemas.openxmlformats.org/presentationml/2006/main">
+  <p:cSld name="Slide 11">
+    <p:bg>
+      <p:bgPr>
+        <a:solidFill>
           <a:srgbClr val="FFFFFF"/>
         </a:solidFill>
       </p:bgPr>
@@ -2440,7 +3628,7 @@
                 <a:ea typeface="Calibri" pitchFamily="34" charset="-122"/>
                 <a:cs typeface="Calibri" pitchFamily="34" charset="-120"/>
               </a:rPr>
-              <a:t>10</a:t>
+              <a:t>11</a:t>
             </a:r>
             <a:endParaRPr lang="en-US" sz="2000" dirty="0"/>
           </a:p>
@@ -6634,12 +7822,12 @@
         </p:nvSpPr>
         <p:spPr>
           <a:xfrm>
-            <a:off x="640080" y="1600200"/>
-            <a:ext cx="10881360" cy="2560320"/>
+            <a:off x="640080" y="1371600"/>
+            <a:ext cx="10881360" cy="1645920"/>
           </a:xfrm>
           <a:prstGeom prst="roundRect">
             <a:avLst>
-              <a:gd name="adj" fmla="val 4286"/>
+              <a:gd name="adj" fmla="val 6667"/>
             </a:avLst>
           </a:prstGeom>
           <a:solidFill>
@@ -6663,7 +7851,7 @@
         </p:nvSpPr>
         <p:spPr>
           <a:xfrm>
-            <a:off x="11210544" y="1746504"/>
+            <a:off x="11210544" y="1517904"/>
             <a:ext cx="128016" cy="128016"/>
           </a:xfrm>
           <a:prstGeom prst="ellipse">
@@ -6683,7 +7871,7 @@
         </p:nvSpPr>
         <p:spPr>
           <a:xfrm>
-            <a:off x="11210544" y="1947672"/>
+            <a:off x="11210544" y="1719072"/>
             <a:ext cx="128016" cy="128016"/>
           </a:xfrm>
           <a:prstGeom prst="ellipse">
@@ -6703,7 +7891,7 @@
         </p:nvSpPr>
         <p:spPr>
           <a:xfrm>
-            <a:off x="11210544" y="2148840"/>
+            <a:off x="11210544" y="1920240"/>
             <a:ext cx="128016" cy="128016"/>
           </a:xfrm>
           <a:prstGeom prst="ellipse">
@@ -6723,7 +7911,7 @@
         </p:nvSpPr>
         <p:spPr>
           <a:xfrm>
-            <a:off x="914400" y="1728216"/>
+            <a:off x="914400" y="1499616"/>
             <a:ext cx="10195560" cy="292608"/>
           </a:xfrm>
           <a:prstGeom prst="rect">
@@ -6748,7 +7936,7 @@
                 <a:ea typeface="Calibri" pitchFamily="34" charset="-122"/>
                 <a:cs typeface="Calibri" pitchFamily="34" charset="-120"/>
               </a:rPr>
-              <a:t>Edit Robot: add the listener, then replace logRunningCommand()</a:t>
+              <a:t>Edit Robot's constructor — add the listener</a:t>
             </a:r>
             <a:endParaRPr lang="en-US" sz="1500" dirty="0"/>
           </a:p>
@@ -6762,8 +7950,8 @@
         </p:nvSpPr>
         <p:spPr>
           <a:xfrm>
-            <a:off x="914400" y="2057400"/>
-            <a:ext cx="10195560" cy="1901952"/>
+            <a:off x="914400" y="1828800"/>
+            <a:ext cx="10195560" cy="987552"/>
           </a:xfrm>
           <a:prstGeom prst="rect">
             <a:avLst/>
@@ -6782,17 +7970,17 @@
               <a:buNone/>
             </a:pPr>
             <a:r>
-              <a:rPr lang="en-US" sz="1200" dirty="0">
-                <a:solidFill>
-                  <a:srgbClr val="9EF01A"/>
+              <a:rPr lang="en-US" sz="1400" dirty="0">
+                <a:solidFill>
+                  <a:srgbClr val="FFD166"/>
                 </a:solidFill>
                 <a:latin typeface="Courier New" pitchFamily="34" charset="0"/>
                 <a:ea typeface="Courier New" pitchFamily="34" charset="-122"/>
                 <a:cs typeface="Courier New" pitchFamily="34" charset="-120"/>
               </a:rPr>
-              <a:t>Scheduler.getDefault().addEventListener(this::logCommandStart);</a:t>
-            </a:r>
-            <a:endParaRPr lang="en-US" sz="1200" dirty="0"/>
+              <a:t>public Robot() {</a:t>
+            </a:r>
+            <a:endParaRPr lang="en-US" sz="1400" dirty="0"/>
           </a:p>
           <a:p>
             <a:pPr indent="0" marL="0">
@@ -6801,7 +7989,18 @@
               </a:lnSpc>
               <a:buNone/>
             </a:pPr>
-            <a:endParaRPr lang="en-US" sz="1200" dirty="0"/>
+            <a:r>
+              <a:rPr lang="en-US" sz="1400" dirty="0">
+                <a:solidFill>
+                  <a:srgbClr val="D7E3F4"/>
+                </a:solidFill>
+                <a:latin typeface="Courier New" pitchFamily="34" charset="0"/>
+                <a:ea typeface="Courier New" pitchFamily="34" charset="-122"/>
+                <a:cs typeface="Courier New" pitchFamily="34" charset="-120"/>
+              </a:rPr>
+              <a:t>  DataLogManager.start(); // saves every published value to a .wpilog file</a:t>
+            </a:r>
+            <a:endParaRPr lang="en-US" sz="1400" dirty="0"/>
           </a:p>
           <a:p>
             <a:pPr indent="0" marL="0">
@@ -6811,17 +8010,17 @@
               <a:buNone/>
             </a:pPr>
             <a:r>
-              <a:rPr lang="en-US" sz="1200" dirty="0">
-                <a:solidFill>
-                  <a:srgbClr val="FFD166"/>
+              <a:rPr lang="en-US" sz="1400" dirty="0">
+                <a:solidFill>
+                  <a:srgbClr val="9EF01A"/>
                 </a:solidFill>
                 <a:latin typeface="Courier New" pitchFamily="34" charset="0"/>
                 <a:ea typeface="Courier New" pitchFamily="34" charset="-122"/>
                 <a:cs typeface="Courier New" pitchFamily="34" charset="-120"/>
               </a:rPr>
-              <a:t>private void logCommandStart(SchedulerEvent event) {</a:t>
-            </a:r>
-            <a:endParaRPr lang="en-US" sz="1200" dirty="0"/>
+              <a:t>  Scheduler.getDefault().addEventListener(this::logCommandStart); // ← added</a:t>
+            </a:r>
+            <a:endParaRPr lang="en-US" sz="1400" dirty="0"/>
           </a:p>
           <a:p>
             <a:pPr indent="0" marL="0">
@@ -6831,7 +8030,7 @@
               <a:buNone/>
             </a:pPr>
             <a:r>
-              <a:rPr lang="en-US" sz="1200" dirty="0">
+              <a:rPr lang="en-US" sz="1400" dirty="0">
                 <a:solidFill>
                   <a:srgbClr val="D7E3F4"/>
                 </a:solidFill>
@@ -6839,10 +8038,160 @@
                 <a:ea typeface="Courier New" pitchFamily="34" charset="-122"/>
                 <a:cs typeface="Courier New" pitchFamily="34" charset="-120"/>
               </a:rPr>
-              <a:t>  if (event instanceof SchedulerEvent.Scheduled scheduled</a:t>
-            </a:r>
-            <a:endParaRPr lang="en-US" sz="1200" dirty="0"/>
-          </a:p>
+              <a:t>}</a:t>
+            </a:r>
+            <a:endParaRPr lang="en-US" sz="1400" dirty="0"/>
+          </a:p>
+        </p:txBody>
+      </p:sp>
+      <p:sp>
+        <p:nvSpPr>
+          <p:cNvPr id="12" name="Shape 9"/>
+          <p:cNvSpPr/>
+          <p:nvPr/>
+        </p:nvSpPr>
+        <p:spPr>
+          <a:xfrm>
+            <a:off x="640080" y="3154680"/>
+            <a:ext cx="10881360" cy="2331720"/>
+          </a:xfrm>
+          <a:prstGeom prst="roundRect">
+            <a:avLst>
+              <a:gd name="adj" fmla="val 4706"/>
+            </a:avLst>
+          </a:prstGeom>
+          <a:solidFill>
+            <a:srgbClr val="0B1F3A"/>
+          </a:solidFill>
+          <a:ln/>
+          <a:effectLst>
+            <a:outerShdw sx="100000" sy="100000" kx="0" ky="0" algn="bl" rotWithShape="0" blurRad="101600" dist="38100" dir="5400000">
+              <a:srgbClr val="0B1F3A">
+                <a:alpha val="35000"/>
+              </a:srgbClr>
+            </a:outerShdw>
+          </a:effectLst>
+        </p:spPr>
+      </p:sp>
+      <p:sp>
+        <p:nvSpPr>
+          <p:cNvPr id="13" name="Shape 10"/>
+          <p:cNvSpPr/>
+          <p:nvPr/>
+        </p:nvSpPr>
+        <p:spPr>
+          <a:xfrm>
+            <a:off x="11210544" y="3300984"/>
+            <a:ext cx="128016" cy="128016"/>
+          </a:xfrm>
+          <a:prstGeom prst="ellipse">
+            <a:avLst/>
+          </a:prstGeom>
+          <a:solidFill>
+            <a:srgbClr val="FF6B6B"/>
+          </a:solidFill>
+          <a:ln/>
+        </p:spPr>
+      </p:sp>
+      <p:sp>
+        <p:nvSpPr>
+          <p:cNvPr id="14" name="Shape 11"/>
+          <p:cNvSpPr/>
+          <p:nvPr/>
+        </p:nvSpPr>
+        <p:spPr>
+          <a:xfrm>
+            <a:off x="11210544" y="3502152"/>
+            <a:ext cx="128016" cy="128016"/>
+          </a:xfrm>
+          <a:prstGeom prst="ellipse">
+            <a:avLst/>
+          </a:prstGeom>
+          <a:solidFill>
+            <a:srgbClr val="FFD166"/>
+          </a:solidFill>
+          <a:ln/>
+        </p:spPr>
+      </p:sp>
+      <p:sp>
+        <p:nvSpPr>
+          <p:cNvPr id="15" name="Shape 12"/>
+          <p:cNvSpPr/>
+          <p:nvPr/>
+        </p:nvSpPr>
+        <p:spPr>
+          <a:xfrm>
+            <a:off x="11210544" y="3703320"/>
+            <a:ext cx="128016" cy="128016"/>
+          </a:xfrm>
+          <a:prstGeom prst="ellipse">
+            <a:avLst/>
+          </a:prstGeom>
+          <a:solidFill>
+            <a:srgbClr val="2EC4B6"/>
+          </a:solidFill>
+          <a:ln/>
+        </p:spPr>
+      </p:sp>
+      <p:sp>
+        <p:nvSpPr>
+          <p:cNvPr id="16" name="Text 13"/>
+          <p:cNvSpPr/>
+          <p:nvPr/>
+        </p:nvSpPr>
+        <p:spPr>
+          <a:xfrm>
+            <a:off x="914400" y="3282696"/>
+            <a:ext cx="10195560" cy="292608"/>
+          </a:xfrm>
+          <a:prstGeom prst="rect">
+            <a:avLst/>
+          </a:prstGeom>
+          <a:noFill/>
+          <a:ln/>
+        </p:spPr>
+        <p:txBody>
+          <a:bodyPr wrap="square" lIns="0" tIns="0" rIns="0" bIns="0" rtlCol="0" anchor="ctr"/>
+          <a:lstStyle/>
+          <a:p>
+            <a:pPr indent="0" marL="0">
+              <a:buNone/>
+            </a:pPr>
+            <a:r>
+              <a:rPr lang="en-US" sz="1500" b="1" dirty="0">
+                <a:solidFill>
+                  <a:srgbClr val="FF5010"/>
+                </a:solidFill>
+                <a:latin typeface="Calibri" pitchFamily="34" charset="0"/>
+                <a:ea typeface="Calibri" pitchFamily="34" charset="-122"/>
+                <a:cs typeface="Calibri" pitchFamily="34" charset="-120"/>
+              </a:rPr>
+              <a:t>Replace logRunningCommand() with</a:t>
+            </a:r>
+            <a:endParaRPr lang="en-US" sz="1500" dirty="0"/>
+          </a:p>
+        </p:txBody>
+      </p:sp>
+      <p:sp>
+        <p:nvSpPr>
+          <p:cNvPr id="17" name="Text 14"/>
+          <p:cNvSpPr/>
+          <p:nvPr/>
+        </p:nvSpPr>
+        <p:spPr>
+          <a:xfrm>
+            <a:off x="914400" y="3611880"/>
+            <a:ext cx="10195560" cy="1673352"/>
+          </a:xfrm>
+          <a:prstGeom prst="rect">
+            <a:avLst/>
+          </a:prstGeom>
+          <a:noFill/>
+          <a:ln/>
+        </p:spPr>
+        <p:txBody>
+          <a:bodyPr wrap="square" lIns="0" tIns="0" rIns="0" bIns="0" rtlCol="0" anchor="t"/>
+          <a:lstStyle/>
           <a:p>
             <a:pPr indent="0" marL="0">
               <a:lnSpc>
@@ -6853,13 +8202,13 @@
             <a:r>
               <a:rPr lang="en-US" sz="1200" dirty="0">
                 <a:solidFill>
-                  <a:srgbClr val="D7E3F4"/>
+                  <a:srgbClr val="FFD166"/>
                 </a:solidFill>
                 <a:latin typeface="Courier New" pitchFamily="34" charset="0"/>
                 <a:ea typeface="Courier New" pitchFamily="34" charset="-122"/>
                 <a:cs typeface="Courier New" pitchFamily="34" charset="-120"/>
               </a:rPr>
-              <a:t>      &amp;&amp; scheduled.command().requires(module)) {</a:t>
+              <a:t>private void logCommandStart(SchedulerEvent event) {</a:t>
             </a:r>
             <a:endParaRPr lang="en-US" sz="1200" dirty="0"/>
           </a:p>
@@ -6873,13 +8222,13 @@
             <a:r>
               <a:rPr lang="en-US" sz="1200" dirty="0">
                 <a:solidFill>
-                  <a:srgbClr val="9EF01A"/>
+                  <a:srgbClr val="D7E3F4"/>
                 </a:solidFill>
                 <a:latin typeface="Courier New" pitchFamily="34" charset="0"/>
                 <a:ea typeface="Courier New" pitchFamily="34" charset="-122"/>
                 <a:cs typeface="Courier New" pitchFamily="34" charset="-120"/>
               </a:rPr>
-              <a:t>    SmartDashboard.putString("DriveModule/CurrentCommand", scheduled.command().name());</a:t>
+              <a:t>  if (event instanceof SchedulerEvent.Scheduled scheduled</a:t>
             </a:r>
             <a:endParaRPr lang="en-US" sz="1200" dirty="0"/>
           </a:p>
@@ -6899,7 +8248,7 @@
                 <a:ea typeface="Courier New" pitchFamily="34" charset="-122"/>
                 <a:cs typeface="Courier New" pitchFamily="34" charset="-120"/>
               </a:rPr>
-              <a:t>  }</a:t>
+              <a:t>      &amp;&amp; scheduled.command().requires(module)) {</a:t>
             </a:r>
             <a:endParaRPr lang="en-US" sz="1200" dirty="0"/>
           </a:p>
@@ -6913,12 +8262,52 @@
             <a:r>
               <a:rPr lang="en-US" sz="1200" dirty="0">
                 <a:solidFill>
-                  <a:srgbClr val="D7E3F4"/>
+                  <a:srgbClr val="9EF01A"/>
                 </a:solidFill>
                 <a:latin typeface="Courier New" pitchFamily="34" charset="0"/>
                 <a:ea typeface="Courier New" pitchFamily="34" charset="-122"/>
                 <a:cs typeface="Courier New" pitchFamily="34" charset="-120"/>
               </a:rPr>
+              <a:t>    SmartDashboard.putString("DriveModule/CurrentCommand", scheduled.command().name());</a:t>
+            </a:r>
+            <a:endParaRPr lang="en-US" sz="1200" dirty="0"/>
+          </a:p>
+          <a:p>
+            <a:pPr indent="0" marL="0">
+              <a:lnSpc>
+                <a:spcPct val="120000"/>
+              </a:lnSpc>
+              <a:buNone/>
+            </a:pPr>
+            <a:r>
+              <a:rPr lang="en-US" sz="1200" dirty="0">
+                <a:solidFill>
+                  <a:srgbClr val="D7E3F4"/>
+                </a:solidFill>
+                <a:latin typeface="Courier New" pitchFamily="34" charset="0"/>
+                <a:ea typeface="Courier New" pitchFamily="34" charset="-122"/>
+                <a:cs typeface="Courier New" pitchFamily="34" charset="-120"/>
+              </a:rPr>
+              <a:t>  }</a:t>
+            </a:r>
+            <a:endParaRPr lang="en-US" sz="1200" dirty="0"/>
+          </a:p>
+          <a:p>
+            <a:pPr indent="0" marL="0">
+              <a:lnSpc>
+                <a:spcPct val="120000"/>
+              </a:lnSpc>
+              <a:buNone/>
+            </a:pPr>
+            <a:r>
+              <a:rPr lang="en-US" sz="1200" dirty="0">
+                <a:solidFill>
+                  <a:srgbClr val="D7E3F4"/>
+                </a:solidFill>
+                <a:latin typeface="Courier New" pitchFamily="34" charset="0"/>
+                <a:ea typeface="Courier New" pitchFamily="34" charset="-122"/>
+                <a:cs typeface="Courier New" pitchFamily="34" charset="-120"/>
+              </a:rPr>
               <a:t>}</a:t>
             </a:r>
             <a:endParaRPr lang="en-US" sz="1200" dirty="0"/>
@@ -6927,18 +8316,18 @@
       </p:sp>
       <p:sp>
         <p:nvSpPr>
-          <p:cNvPr id="12" name="Shape 9"/>
-          <p:cNvSpPr/>
-          <p:nvPr/>
-        </p:nvSpPr>
-        <p:spPr>
-          <a:xfrm>
-            <a:off x="640080" y="4297680"/>
-            <a:ext cx="10881360" cy="2103120"/>
+          <p:cNvPr id="18" name="Shape 15"/>
+          <p:cNvSpPr/>
+          <p:nvPr/>
+        </p:nvSpPr>
+        <p:spPr>
+          <a:xfrm>
+            <a:off x="640080" y="5532120"/>
+            <a:ext cx="10881360" cy="868680"/>
           </a:xfrm>
           <a:prstGeom prst="roundRect">
             <a:avLst>
-              <a:gd name="adj" fmla="val 4348"/>
+              <a:gd name="adj" fmla="val 10526"/>
             </a:avLst>
           </a:prstGeom>
           <a:solidFill>
@@ -6949,56 +8338,14 @@
       </p:sp>
       <p:sp>
         <p:nvSpPr>
-          <p:cNvPr id="13" name="Text 10"/>
-          <p:cNvSpPr/>
-          <p:nvPr/>
-        </p:nvSpPr>
-        <p:spPr>
-          <a:xfrm>
-            <a:off x="914400" y="4572000"/>
-            <a:ext cx="10332720" cy="546100"/>
-          </a:xfrm>
-          <a:prstGeom prst="rect">
-            <a:avLst/>
-          </a:prstGeom>
-          <a:noFill/>
-          <a:ln/>
-        </p:spPr>
-        <p:txBody>
-          <a:bodyPr wrap="square" lIns="0" tIns="0" rIns="0" bIns="0" rtlCol="0" anchor="t"/>
-          <a:lstStyle/>
-          <a:p>
-            <a:pPr indent="0" marL="0">
-              <a:lnSpc>
-                <a:spcPct val="120000"/>
-              </a:lnSpc>
-              <a:buNone/>
-            </a:pPr>
-            <a:r>
-              <a:rPr lang="en-US" sz="2000" b="1" dirty="0">
-                <a:solidFill>
-                  <a:srgbClr val="13294B"/>
-                </a:solidFill>
-                <a:latin typeface="Cambria" pitchFamily="34" charset="0"/>
-                <a:ea typeface="Cambria" pitchFamily="34" charset="-122"/>
-                <a:cs typeface="Cambria" pitchFamily="34" charset="-120"/>
-              </a:rPr>
-              <a:t>Is this a Scheduled event? Type it as one.</a:t>
-            </a:r>
-            <a:endParaRPr lang="en-US" sz="2000" dirty="0"/>
-          </a:p>
-        </p:txBody>
-      </p:sp>
-      <p:sp>
-        <p:nvSpPr>
-          <p:cNvPr id="14" name="Text 11"/>
-          <p:cNvSpPr/>
-          <p:nvPr/>
-        </p:nvSpPr>
-        <p:spPr>
-          <a:xfrm>
-            <a:off x="914400" y="5118100"/>
-            <a:ext cx="10332720" cy="1008380"/>
+          <p:cNvPr id="19" name="Text 16"/>
+          <p:cNvSpPr/>
+          <p:nvPr/>
+        </p:nvSpPr>
+        <p:spPr>
+          <a:xfrm>
+            <a:off x="777240" y="5669280"/>
+            <a:ext cx="10607040" cy="594360"/>
           </a:xfrm>
           <a:prstGeom prst="rect">
             <a:avLst/>
@@ -7017,7 +8364,7 @@
               <a:buNone/>
             </a:pPr>
             <a:r>
-              <a:rPr lang="en-US" sz="2000" dirty="0">
+              <a:rPr lang="en-US" sz="1600" dirty="0">
                 <a:solidFill>
                   <a:srgbClr val="13294B"/>
                 </a:solidFill>
@@ -7025,15 +8372,15 @@
                 <a:ea typeface="Calibri" pitchFamily="34" charset="-122"/>
                 <a:cs typeface="Calibri" pitchFamily="34" charset="-120"/>
               </a:rPr>
-              <a:t>Only the specific kind has .command() on it. The old version polled and got lucky every time; this one can't get unlucky — it isn't asking, it's told.</a:t>
-            </a:r>
-            <a:endParaRPr lang="en-US" sz="2000" dirty="0"/>
-          </a:p>
-        </p:txBody>
-      </p:sp>
-      <p:sp>
-        <p:nvSpPr>
-          <p:cNvPr id="15" name="Text 12"/>
+              <a:t>Is this a Scheduled event? Type it as one, right there — that's pattern matching. The old version polled and got lucky every time; this one is told.</a:t>
+            </a:r>
+            <a:endParaRPr lang="en-US" sz="1600" dirty="0"/>
+          </a:p>
+        </p:txBody>
+      </p:sp>
+      <p:sp>
+        <p:nvSpPr>
+          <p:cNvPr id="20" name="Text 17"/>
           <p:cNvSpPr/>
           <p:nvPr/>
         </p:nvSpPr>
@@ -7072,7 +8419,7 @@
       </p:sp>
       <p:sp>
         <p:nvSpPr>
-          <p:cNvPr id="16" name="Text 13"/>
+          <p:cNvPr id="21" name="Text 18"/>
           <p:cNvSpPr/>
           <p:nvPr/>
         </p:nvSpPr>
@@ -7111,7 +8458,7 @@
       </p:sp>
       <p:pic>
         <p:nvPicPr>
-          <p:cNvPr id="17" name="Image 1" descr="/home/user/BasicRobotLessons/docs/presentations/v3/template/assets/logo/team5010-logo-onwhite.png">    </p:cNvPr>
+          <p:cNvPr id="22" name="Image 1" descr="/home/user/BasicRobotLessons/docs/presentations/v3/template/assets/logo/team5010-logo-onwhite.png">    </p:cNvPr>
           <p:cNvPicPr>
             <a:picLocks noChangeAspect="1"/>
           </p:cNvPicPr>
@@ -7147,7 +8494,7 @@
     <p:bg>
       <p:bgPr>
         <a:solidFill>
-          <a:srgbClr val="0B1F3A"/>
+          <a:srgbClr val="FFFFFF"/>
         </a:solidFill>
       </p:bgPr>
     </p:bg>
@@ -7180,14 +8527,14 @@
             <a:avLst/>
           </a:prstGeom>
           <a:solidFill>
-            <a:srgbClr val="FF5010"/>
+            <a:srgbClr val="0B1F3A"/>
           </a:solidFill>
           <a:ln/>
         </p:spPr>
       </p:sp>
       <p:pic>
         <p:nvPicPr>
-          <p:cNvPr id="3" name="Image 0" descr="/home/user/BasicRobotLessons/docs/presentations/v3/template/assets/icons/clipboardcheck_white.png">    </p:cNvPr>
+          <p:cNvPr id="3" name="Image 0" descr="/home/user/BasicRobotLessons/docs/presentations/v3/template/assets/icons/compressarrowsalt_white.png">    </p:cNvPr>
           <p:cNvPicPr>
             <a:picLocks noChangeAspect="1"/>
           </p:cNvPicPr>
@@ -7234,15 +8581,15 @@
               <a:buNone/>
             </a:pPr>
             <a:r>
-              <a:rPr lang="en-US" sz="2000" b="1" spc="100" kern="0" dirty="0">
-                <a:solidFill>
-                  <a:srgbClr val="1B9AAA"/>
+              <a:rPr lang="en-US" sz="2000" b="1" spc="150" kern="0" dirty="0">
+                <a:solidFill>
+                  <a:srgbClr val="FF5010"/>
                 </a:solidFill>
                 <a:latin typeface="Calibri" pitchFamily="34" charset="0"/>
                 <a:ea typeface="Calibri" pitchFamily="34" charset="-122"/>
                 <a:cs typeface="Calibri" pitchFamily="34" charset="-120"/>
               </a:rPr>
-              <a:t>BEFORE YOU MOVE ON</a:t>
+              <a:t>SECTION 6 CONTINUED · ROBOT.JAVA</a:t>
             </a:r>
             <a:endParaRPr lang="en-US" sz="2000" dirty="0"/>
           </a:p>
@@ -7275,13 +8622,13 @@
             <a:r>
               <a:rPr lang="en-US" sz="3000" b="1" dirty="0">
                 <a:solidFill>
-                  <a:srgbClr val="FFFFFF"/>
+                  <a:srgbClr val="13294B"/>
                 </a:solidFill>
                 <a:latin typeface="Cambria" pitchFamily="34" charset="0"/>
                 <a:ea typeface="Cambria" pitchFamily="34" charset="-122"/>
                 <a:cs typeface="Cambria" pitchFamily="34" charset="-120"/>
               </a:rPr>
-              <a:t>Try it</a:t>
+              <a:t>The command log takes care of itself now</a:t>
             </a:r>
             <a:endParaRPr lang="en-US" sz="3000" dirty="0"/>
           </a:p>
@@ -7295,18 +8642,25 @@
         </p:nvSpPr>
         <p:spPr>
           <a:xfrm>
-            <a:off x="640080" y="1463040"/>
-            <a:ext cx="5303520" cy="2286000"/>
+            <a:off x="640080" y="1600200"/>
+            <a:ext cx="10881360" cy="2011680"/>
           </a:xfrm>
           <a:prstGeom prst="roundRect">
             <a:avLst>
-              <a:gd name="adj" fmla="val 4800"/>
+              <a:gd name="adj" fmla="val 5455"/>
             </a:avLst>
           </a:prstGeom>
           <a:solidFill>
-            <a:srgbClr val="132A4C"/>
+            <a:srgbClr val="0B1F3A"/>
           </a:solidFill>
           <a:ln/>
+          <a:effectLst>
+            <a:outerShdw sx="100000" sy="100000" kx="0" ky="0" algn="bl" rotWithShape="0" blurRad="101600" dist="38100" dir="5400000">
+              <a:srgbClr val="0B1F3A">
+                <a:alpha val="35000"/>
+              </a:srgbClr>
+            </a:outerShdw>
+          </a:effectLst>
         </p:spPr>
       </p:sp>
       <p:sp>
@@ -7317,28 +8671,68 @@
         </p:nvSpPr>
         <p:spPr>
           <a:xfrm>
-            <a:off x="960120" y="1691640"/>
-            <a:ext cx="457200" cy="457200"/>
+            <a:off x="11210544" y="1746504"/>
+            <a:ext cx="128016" cy="128016"/>
           </a:xfrm>
           <a:prstGeom prst="ellipse">
             <a:avLst/>
           </a:prstGeom>
           <a:solidFill>
-            <a:srgbClr val="1B9AAA"/>
+            <a:srgbClr val="FF6B6B"/>
           </a:solidFill>
           <a:ln/>
         </p:spPr>
       </p:sp>
       <p:sp>
         <p:nvSpPr>
-          <p:cNvPr id="8" name="Text 5"/>
-          <p:cNvSpPr/>
-          <p:nvPr/>
-        </p:nvSpPr>
-        <p:spPr>
-          <a:xfrm>
-            <a:off x="960120" y="1691640"/>
-            <a:ext cx="457200" cy="457200"/>
+          <p:cNvPr id="8" name="Shape 5"/>
+          <p:cNvSpPr/>
+          <p:nvPr/>
+        </p:nvSpPr>
+        <p:spPr>
+          <a:xfrm>
+            <a:off x="11210544" y="1947672"/>
+            <a:ext cx="128016" cy="128016"/>
+          </a:xfrm>
+          <a:prstGeom prst="ellipse">
+            <a:avLst/>
+          </a:prstGeom>
+          <a:solidFill>
+            <a:srgbClr val="FFD166"/>
+          </a:solidFill>
+          <a:ln/>
+        </p:spPr>
+      </p:sp>
+      <p:sp>
+        <p:nvSpPr>
+          <p:cNvPr id="9" name="Shape 6"/>
+          <p:cNvSpPr/>
+          <p:nvPr/>
+        </p:nvSpPr>
+        <p:spPr>
+          <a:xfrm>
+            <a:off x="11210544" y="2148840"/>
+            <a:ext cx="128016" cy="128016"/>
+          </a:xfrm>
+          <a:prstGeom prst="ellipse">
+            <a:avLst/>
+          </a:prstGeom>
+          <a:solidFill>
+            <a:srgbClr val="2EC4B6"/>
+          </a:solidFill>
+          <a:ln/>
+        </p:spPr>
+      </p:sp>
+      <p:sp>
+        <p:nvSpPr>
+          <p:cNvPr id="10" name="Text 7"/>
+          <p:cNvSpPr/>
+          <p:nvPr/>
+        </p:nvSpPr>
+        <p:spPr>
+          <a:xfrm>
+            <a:off x="914400" y="1728216"/>
+            <a:ext cx="10195560" cy="292608"/>
           </a:xfrm>
           <a:prstGeom prst="rect">
             <a:avLst/>
@@ -7350,76 +8744,200 @@
           <a:bodyPr wrap="square" lIns="0" tIns="0" rIns="0" bIns="0" rtlCol="0" anchor="ctr"/>
           <a:lstStyle/>
           <a:p>
-            <a:pPr algn="ctr" indent="0" marL="0">
-              <a:buNone/>
-            </a:pPr>
-            <a:r>
-              <a:rPr lang="en-US" sz="2200" b="1" dirty="0">
-                <a:solidFill>
-                  <a:srgbClr val="FFFFFF"/>
+            <a:pPr indent="0" marL="0">
+              <a:buNone/>
+            </a:pPr>
+            <a:r>
+              <a:rPr lang="en-US" sz="1500" b="1" dirty="0">
+                <a:solidFill>
+                  <a:srgbClr val="FF5010"/>
+                </a:solidFill>
+                <a:latin typeface="Calibri" pitchFamily="34" charset="0"/>
+                <a:ea typeface="Calibri" pitchFamily="34" charset="-122"/>
+                <a:cs typeface="Calibri" pitchFamily="34" charset="-120"/>
+              </a:rPr>
+              <a:t>Edit Robot's robotPeriodic(), dropping the call to the old method</a:t>
+            </a:r>
+            <a:endParaRPr lang="en-US" sz="1500" dirty="0"/>
+          </a:p>
+        </p:txBody>
+      </p:sp>
+      <p:sp>
+        <p:nvSpPr>
+          <p:cNvPr id="11" name="Text 8"/>
+          <p:cNvSpPr/>
+          <p:nvPr/>
+        </p:nvSpPr>
+        <p:spPr>
+          <a:xfrm>
+            <a:off x="914400" y="2057400"/>
+            <a:ext cx="10195560" cy="1353312"/>
+          </a:xfrm>
+          <a:prstGeom prst="rect">
+            <a:avLst/>
+          </a:prstGeom>
+          <a:noFill/>
+          <a:ln/>
+        </p:spPr>
+        <p:txBody>
+          <a:bodyPr wrap="square" lIns="0" tIns="0" rIns="0" bIns="0" rtlCol="0" anchor="t"/>
+          <a:lstStyle/>
+          <a:p>
+            <a:pPr indent="0" marL="0">
+              <a:lnSpc>
+                <a:spcPct val="120000"/>
+              </a:lnSpc>
+              <a:buNone/>
+            </a:pPr>
+            <a:r>
+              <a:rPr lang="en-US" sz="1700" dirty="0">
+                <a:solidFill>
+                  <a:srgbClr val="FFD166"/>
+                </a:solidFill>
+                <a:latin typeface="Courier New" pitchFamily="34" charset="0"/>
+                <a:ea typeface="Courier New" pitchFamily="34" charset="-122"/>
+                <a:cs typeface="Courier New" pitchFamily="34" charset="-120"/>
+              </a:rPr>
+              <a:t>@Override</a:t>
+            </a:r>
+            <a:endParaRPr lang="en-US" sz="1700" dirty="0"/>
+          </a:p>
+          <a:p>
+            <a:pPr indent="0" marL="0">
+              <a:lnSpc>
+                <a:spcPct val="120000"/>
+              </a:lnSpc>
+              <a:buNone/>
+            </a:pPr>
+            <a:r>
+              <a:rPr lang="en-US" sz="1700" dirty="0">
+                <a:solidFill>
+                  <a:srgbClr val="D7E3F4"/>
+                </a:solidFill>
+                <a:latin typeface="Courier New" pitchFamily="34" charset="0"/>
+                <a:ea typeface="Courier New" pitchFamily="34" charset="-122"/>
+                <a:cs typeface="Courier New" pitchFamily="34" charset="-120"/>
+              </a:rPr>
+              <a:t>public void robotPeriodic() {</a:t>
+            </a:r>
+            <a:endParaRPr lang="en-US" sz="1700" dirty="0"/>
+          </a:p>
+          <a:p>
+            <a:pPr indent="0" marL="0">
+              <a:lnSpc>
+                <a:spcPct val="120000"/>
+              </a:lnSpc>
+              <a:buNone/>
+            </a:pPr>
+            <a:r>
+              <a:rPr lang="en-US" sz="1700" dirty="0">
+                <a:solidFill>
+                  <a:srgbClr val="9EF01A"/>
+                </a:solidFill>
+                <a:latin typeface="Courier New" pitchFamily="34" charset="0"/>
+                <a:ea typeface="Courier New" pitchFamily="34" charset="-122"/>
+                <a:cs typeface="Courier New" pitchFamily="34" charset="-120"/>
+              </a:rPr>
+              <a:t>  Scheduler.getDefault().run();</a:t>
+            </a:r>
+            <a:endParaRPr lang="en-US" sz="1700" dirty="0"/>
+          </a:p>
+          <a:p>
+            <a:pPr indent="0" marL="0">
+              <a:lnSpc>
+                <a:spcPct val="120000"/>
+              </a:lnSpc>
+              <a:buNone/>
+            </a:pPr>
+            <a:r>
+              <a:rPr lang="en-US" sz="1700" dirty="0">
+                <a:solidFill>
+                  <a:srgbClr val="D7E3F4"/>
+                </a:solidFill>
+                <a:latin typeface="Courier New" pitchFamily="34" charset="0"/>
+                <a:ea typeface="Courier New" pitchFamily="34" charset="-122"/>
+                <a:cs typeface="Courier New" pitchFamily="34" charset="-120"/>
+              </a:rPr>
+              <a:t>}</a:t>
+            </a:r>
+            <a:endParaRPr lang="en-US" sz="1700" dirty="0"/>
+          </a:p>
+        </p:txBody>
+      </p:sp>
+      <p:sp>
+        <p:nvSpPr>
+          <p:cNvPr id="12" name="Shape 9"/>
+          <p:cNvSpPr/>
+          <p:nvPr/>
+        </p:nvSpPr>
+        <p:spPr>
+          <a:xfrm>
+            <a:off x="640080" y="3794760"/>
+            <a:ext cx="10881360" cy="2514600"/>
+          </a:xfrm>
+          <a:prstGeom prst="roundRect">
+            <a:avLst>
+              <a:gd name="adj" fmla="val 3636"/>
+            </a:avLst>
+          </a:prstGeom>
+          <a:solidFill>
+            <a:srgbClr val="F3F6FA"/>
+          </a:solidFill>
+          <a:ln/>
+        </p:spPr>
+      </p:sp>
+      <p:sp>
+        <p:nvSpPr>
+          <p:cNvPr id="13" name="Text 10"/>
+          <p:cNvSpPr/>
+          <p:nvPr/>
+        </p:nvSpPr>
+        <p:spPr>
+          <a:xfrm>
+            <a:off x="914400" y="4069080"/>
+            <a:ext cx="10332720" cy="895350"/>
+          </a:xfrm>
+          <a:prstGeom prst="rect">
+            <a:avLst/>
+          </a:prstGeom>
+          <a:noFill/>
+          <a:ln/>
+        </p:spPr>
+        <p:txBody>
+          <a:bodyPr wrap="square" lIns="0" tIns="0" rIns="0" bIns="0" rtlCol="0" anchor="t"/>
+          <a:lstStyle/>
+          <a:p>
+            <a:pPr indent="0" marL="0">
+              <a:lnSpc>
+                <a:spcPct val="120000"/>
+              </a:lnSpc>
+              <a:buNone/>
+            </a:pPr>
+            <a:r>
+              <a:rPr lang="en-US" sz="2100" b="1" dirty="0">
+                <a:solidFill>
+                  <a:srgbClr val="13294B"/>
                 </a:solidFill>
                 <a:latin typeface="Cambria" pitchFamily="34" charset="0"/>
                 <a:ea typeface="Cambria" pitchFamily="34" charset="-122"/>
                 <a:cs typeface="Cambria" pitchFamily="34" charset="-120"/>
               </a:rPr>
-              <a:t>1</a:t>
-            </a:r>
-            <a:endParaRPr lang="en-US" sz="2200" dirty="0"/>
-          </a:p>
-        </p:txBody>
-      </p:sp>
-      <p:sp>
-        <p:nvSpPr>
-          <p:cNvPr id="9" name="Text 6"/>
-          <p:cNvSpPr/>
-          <p:nvPr/>
-        </p:nvSpPr>
-        <p:spPr>
-          <a:xfrm>
-            <a:off x="1600200" y="1691640"/>
-            <a:ext cx="4023360" cy="457200"/>
-          </a:xfrm>
-          <a:prstGeom prst="rect">
-            <a:avLst/>
-          </a:prstGeom>
-          <a:noFill/>
-          <a:ln/>
-        </p:spPr>
-        <p:txBody>
-          <a:bodyPr wrap="square" lIns="0" tIns="0" rIns="0" bIns="0" rtlCol="0" anchor="ctr"/>
-          <a:lstStyle/>
-          <a:p>
-            <a:pPr indent="0" marL="0">
-              <a:lnSpc>
-                <a:spcPct val="110000"/>
-              </a:lnSpc>
-              <a:buNone/>
-            </a:pPr>
-            <a:r>
-              <a:rPr lang="en-US" sz="2000" b="1" dirty="0">
-                <a:solidFill>
-                  <a:srgbClr val="FFFFFF"/>
-                </a:solidFill>
-                <a:latin typeface="Cambria" pitchFamily="34" charset="0"/>
-                <a:ea typeface="Cambria" pitchFamily="34" charset="-122"/>
-                <a:cs typeface="Cambria" pitchFamily="34" charset="-120"/>
-              </a:rPr>
-              <a:t>Log the commanded speed</a:t>
-            </a:r>
-            <a:endParaRPr lang="en-US" sz="2000" dirty="0"/>
-          </a:p>
-        </p:txBody>
-      </p:sp>
-      <p:sp>
-        <p:nvSpPr>
-          <p:cNvPr id="10" name="Text 7"/>
-          <p:cNvSpPr/>
-          <p:nvPr/>
-        </p:nvSpPr>
-        <p:spPr>
-          <a:xfrm>
-            <a:off x="960120" y="2286000"/>
-            <a:ext cx="4663440" cy="1188720"/>
+              <a:t>Ticking the scheduler is still the only thing that has to happen every tick.</a:t>
+            </a:r>
+            <a:endParaRPr lang="en-US" sz="2100" dirty="0"/>
+          </a:p>
+        </p:txBody>
+      </p:sp>
+      <p:sp>
+        <p:nvSpPr>
+          <p:cNvPr id="14" name="Text 11"/>
+          <p:cNvSpPr/>
+          <p:nvPr/>
+        </p:nvSpPr>
+        <p:spPr>
+          <a:xfrm>
+            <a:off x="914400" y="4964430"/>
+            <a:ext cx="10332720" cy="1070610"/>
           </a:xfrm>
           <a:prstGeom prst="rect">
             <a:avLst/>
@@ -7440,13 +8958,13 @@
             <a:r>
               <a:rPr lang="en-US" sz="2000" dirty="0">
                 <a:solidFill>
-                  <a:srgbClr val="CADCE8"/>
+                  <a:srgbClr val="13294B"/>
                 </a:solidFill>
                 <a:latin typeface="Calibri" pitchFamily="34" charset="0"/>
                 <a:ea typeface="Calibri" pitchFamily="34" charset="-122"/>
                 <a:cs typeface="Calibri" pitchFamily="34" charset="-120"/>
               </a:rPr>
-              <a:t>Inside driveWithJoystick's loop, log CommandedOutput right where it's computed.</a:t>
+              <a:t>Remove the now-unused imports (java.util.List and org.wpilib.command3.Command — nothing here needs them anymore) and add org.wpilib.command3.SchedulerEvent. What changed is how Robot knows what's running, not what shows up on the dashboard.</a:t>
             </a:r>
             <a:endParaRPr lang="en-US" sz="2000" dirty="0"/>
           </a:p>
@@ -7454,56 +8972,14 @@
       </p:sp>
       <p:sp>
         <p:nvSpPr>
-          <p:cNvPr id="11" name="Shape 8"/>
-          <p:cNvSpPr/>
-          <p:nvPr/>
-        </p:nvSpPr>
-        <p:spPr>
-          <a:xfrm>
-            <a:off x="6217920" y="1463040"/>
-            <a:ext cx="5303520" cy="2286000"/>
-          </a:xfrm>
-          <a:prstGeom prst="roundRect">
-            <a:avLst>
-              <a:gd name="adj" fmla="val 4800"/>
-            </a:avLst>
-          </a:prstGeom>
-          <a:solidFill>
-            <a:srgbClr val="132A4C"/>
-          </a:solidFill>
-          <a:ln/>
-        </p:spPr>
-      </p:sp>
-      <p:sp>
-        <p:nvSpPr>
-          <p:cNvPr id="12" name="Shape 9"/>
-          <p:cNvSpPr/>
-          <p:nvPr/>
-        </p:nvSpPr>
-        <p:spPr>
-          <a:xfrm>
-            <a:off x="6537960" y="1691640"/>
-            <a:ext cx="457200" cy="457200"/>
-          </a:xfrm>
-          <a:prstGeom prst="ellipse">
-            <a:avLst/>
-          </a:prstGeom>
-          <a:solidFill>
-            <a:srgbClr val="1B9AAA"/>
-          </a:solidFill>
-          <a:ln/>
-        </p:spPr>
-      </p:sp>
-      <p:sp>
-        <p:nvSpPr>
-          <p:cNvPr id="13" name="Text 10"/>
-          <p:cNvSpPr/>
-          <p:nvPr/>
-        </p:nvSpPr>
-        <p:spPr>
-          <a:xfrm>
-            <a:off x="6537960" y="1691640"/>
-            <a:ext cx="457200" cy="457200"/>
+          <p:cNvPr id="15" name="Text 12"/>
+          <p:cNvSpPr/>
+          <p:nvPr/>
+        </p:nvSpPr>
+        <p:spPr>
+          <a:xfrm>
+            <a:off x="640080" y="6446520"/>
+            <a:ext cx="8229600" cy="365760"/>
           </a:xfrm>
           <a:prstGeom prst="rect">
             <a:avLst/>
@@ -7515,103 +8991,19 @@
           <a:bodyPr wrap="square" lIns="0" tIns="0" rIns="0" bIns="0" rtlCol="0" anchor="ctr"/>
           <a:lstStyle/>
           <a:p>
-            <a:pPr algn="ctr" indent="0" marL="0">
-              <a:buNone/>
-            </a:pPr>
-            <a:r>
-              <a:rPr lang="en-US" sz="2200" b="1" dirty="0">
-                <a:solidFill>
-                  <a:srgbClr val="FFFFFF"/>
-                </a:solidFill>
-                <a:latin typeface="Cambria" pitchFamily="34" charset="0"/>
-                <a:ea typeface="Cambria" pitchFamily="34" charset="-122"/>
-                <a:cs typeface="Cambria" pitchFamily="34" charset="-120"/>
-              </a:rPr>
-              <a:t>2</a:t>
-            </a:r>
-            <a:endParaRPr lang="en-US" sz="2200" dirty="0"/>
-          </a:p>
-        </p:txBody>
-      </p:sp>
-      <p:sp>
-        <p:nvSpPr>
-          <p:cNvPr id="14" name="Text 11"/>
-          <p:cNvSpPr/>
-          <p:nvPr/>
-        </p:nvSpPr>
-        <p:spPr>
-          <a:xfrm>
-            <a:off x="7178040" y="1691640"/>
-            <a:ext cx="4023360" cy="457200"/>
-          </a:xfrm>
-          <a:prstGeom prst="rect">
-            <a:avLst/>
-          </a:prstGeom>
-          <a:noFill/>
-          <a:ln/>
-        </p:spPr>
-        <p:txBody>
-          <a:bodyPr wrap="square" lIns="0" tIns="0" rIns="0" bIns="0" rtlCol="0" anchor="ctr"/>
-          <a:lstStyle/>
-          <a:p>
-            <a:pPr indent="0" marL="0">
-              <a:lnSpc>
-                <a:spcPct val="110000"/>
-              </a:lnSpc>
-              <a:buNone/>
-            </a:pPr>
-            <a:r>
-              <a:rPr lang="en-US" sz="2000" b="1" dirty="0">
-                <a:solidFill>
-                  <a:srgbClr val="FFFFFF"/>
-                </a:solidFill>
-                <a:latin typeface="Cambria" pitchFamily="34" charset="0"/>
-                <a:ea typeface="Cambria" pitchFamily="34" charset="-122"/>
-                <a:cs typeface="Cambria" pitchFamily="34" charset="-120"/>
-              </a:rPr>
-              <a:t>Add getPositionRotations()</a:t>
-            </a:r>
-            <a:endParaRPr lang="en-US" sz="2000" dirty="0"/>
-          </a:p>
-        </p:txBody>
-      </p:sp>
-      <p:sp>
-        <p:nvSpPr>
-          <p:cNvPr id="15" name="Text 12"/>
-          <p:cNvSpPr/>
-          <p:nvPr/>
-        </p:nvSpPr>
-        <p:spPr>
-          <a:xfrm>
-            <a:off x="6537960" y="2286000"/>
-            <a:ext cx="4663440" cy="1188720"/>
-          </a:xfrm>
-          <a:prstGeom prst="rect">
-            <a:avLst/>
-          </a:prstGeom>
-          <a:noFill/>
-          <a:ln/>
-        </p:spPr>
-        <p:txBody>
-          <a:bodyPr wrap="square" lIns="0" tIns="0" rIns="0" bIns="0" rtlCol="0" anchor="t"/>
-          <a:lstStyle/>
-          <a:p>
-            <a:pPr indent="0" marL="0">
-              <a:lnSpc>
-                <a:spcPct val="125000"/>
-              </a:lnSpc>
-              <a:buNone/>
-            </a:pPr>
-            <a:r>
-              <a:rPr lang="en-US" sz="2000" dirty="0">
-                <a:solidFill>
-                  <a:srgbClr val="CADCE8"/>
+            <a:pPr indent="0" marL="0">
+              <a:buNone/>
+            </a:pPr>
+            <a:r>
+              <a:rPr lang="en-US" sz="2000" spc="100" kern="0" dirty="0">
+                <a:solidFill>
+                  <a:srgbClr val="5B6B84"/>
                 </a:solidFill>
                 <a:latin typeface="Calibri" pitchFamily="34" charset="0"/>
                 <a:ea typeface="Calibri" pitchFamily="34" charset="-122"/>
                 <a:cs typeface="Calibri" pitchFamily="34" charset="-120"/>
               </a:rPr>
-              <a:t>A reading method returning position as a double — safe to share, unlike a command.</a:t>
+              <a:t>LEARN JAVA + ROBOT PROGRAMMING · TELEMETRY</a:t>
             </a:r>
             <a:endParaRPr lang="en-US" sz="2000" dirty="0"/>
           </a:p>
@@ -7619,56 +9011,14 @@
       </p:sp>
       <p:sp>
         <p:nvSpPr>
-          <p:cNvPr id="16" name="Shape 13"/>
-          <p:cNvSpPr/>
-          <p:nvPr/>
-        </p:nvSpPr>
-        <p:spPr>
-          <a:xfrm>
-            <a:off x="640080" y="4023360"/>
-            <a:ext cx="5303520" cy="2286000"/>
-          </a:xfrm>
-          <a:prstGeom prst="roundRect">
-            <a:avLst>
-              <a:gd name="adj" fmla="val 4800"/>
-            </a:avLst>
-          </a:prstGeom>
-          <a:solidFill>
-            <a:srgbClr val="132A4C"/>
-          </a:solidFill>
-          <a:ln/>
-        </p:spPr>
-      </p:sp>
-      <p:sp>
-        <p:nvSpPr>
-          <p:cNvPr id="17" name="Shape 14"/>
-          <p:cNvSpPr/>
-          <p:nvPr/>
-        </p:nvSpPr>
-        <p:spPr>
-          <a:xfrm>
-            <a:off x="960120" y="4251960"/>
-            <a:ext cx="457200" cy="457200"/>
-          </a:xfrm>
-          <a:prstGeom prst="ellipse">
-            <a:avLst/>
-          </a:prstGeom>
-          <a:solidFill>
-            <a:srgbClr val="1B9AAA"/>
-          </a:solidFill>
-          <a:ln/>
-        </p:spPr>
-      </p:sp>
-      <p:sp>
-        <p:nvSpPr>
-          <p:cNvPr id="18" name="Text 15"/>
-          <p:cNvSpPr/>
-          <p:nvPr/>
-        </p:nvSpPr>
-        <p:spPr>
-          <a:xfrm>
-            <a:off x="960120" y="4251960"/>
-            <a:ext cx="457200" cy="457200"/>
+          <p:cNvPr id="16" name="Text 13"/>
+          <p:cNvSpPr/>
+          <p:nvPr/>
+        </p:nvSpPr>
+        <p:spPr>
+          <a:xfrm>
+            <a:off x="11002975" y="6446520"/>
+            <a:ext cx="548640" cy="365760"/>
           </a:xfrm>
           <a:prstGeom prst="rect">
             <a:avLst/>
@@ -7680,345 +9030,18 @@
           <a:bodyPr wrap="square" lIns="0" tIns="0" rIns="0" bIns="0" rtlCol="0" anchor="ctr"/>
           <a:lstStyle/>
           <a:p>
-            <a:pPr algn="ctr" indent="0" marL="0">
-              <a:buNone/>
-            </a:pPr>
-            <a:r>
-              <a:rPr lang="en-US" sz="2200" b="1" dirty="0">
-                <a:solidFill>
-                  <a:srgbClr val="FFFFFF"/>
-                </a:solidFill>
-                <a:latin typeface="Cambria" pitchFamily="34" charset="0"/>
-                <a:ea typeface="Cambria" pitchFamily="34" charset="-122"/>
-                <a:cs typeface="Cambria" pitchFamily="34" charset="-120"/>
-              </a:rPr>
-              <a:t>3</a:t>
-            </a:r>
-            <a:endParaRPr lang="en-US" sz="2200" dirty="0"/>
-          </a:p>
-        </p:txBody>
-      </p:sp>
-      <p:sp>
-        <p:nvSpPr>
-          <p:cNvPr id="19" name="Text 16"/>
-          <p:cNvSpPr/>
-          <p:nvPr/>
-        </p:nvSpPr>
-        <p:spPr>
-          <a:xfrm>
-            <a:off x="1600200" y="4251960"/>
-            <a:ext cx="4023360" cy="457200"/>
-          </a:xfrm>
-          <a:prstGeom prst="rect">
-            <a:avLst/>
-          </a:prstGeom>
-          <a:noFill/>
-          <a:ln/>
-        </p:spPr>
-        <p:txBody>
-          <a:bodyPr wrap="square" lIns="0" tIns="0" rIns="0" bIns="0" rtlCol="0" anchor="ctr"/>
-          <a:lstStyle/>
-          <a:p>
-            <a:pPr indent="0" marL="0">
-              <a:lnSpc>
-                <a:spcPct val="110000"/>
-              </a:lnSpc>
-              <a:buNone/>
-            </a:pPr>
-            <a:r>
-              <a:rPr lang="en-US" sz="2000" b="1" dirty="0">
-                <a:solidFill>
-                  <a:srgbClr val="FFFFFF"/>
-                </a:solidFill>
-                <a:latin typeface="Cambria" pitchFamily="34" charset="0"/>
-                <a:ea typeface="Cambria" pitchFamily="34" charset="-122"/>
-                <a:cs typeface="Cambria" pitchFamily="34" charset="-120"/>
-              </a:rPr>
-              <a:t>Rename a dashboard key</a:t>
-            </a:r>
-            <a:endParaRPr lang="en-US" sz="2000" dirty="0"/>
-          </a:p>
-        </p:txBody>
-      </p:sp>
-      <p:sp>
-        <p:nvSpPr>
-          <p:cNvPr id="20" name="Text 17"/>
-          <p:cNvSpPr/>
-          <p:nvPr/>
-        </p:nvSpPr>
-        <p:spPr>
-          <a:xfrm>
-            <a:off x="960120" y="4846320"/>
-            <a:ext cx="4663440" cy="1188720"/>
-          </a:xfrm>
-          <a:prstGeom prst="rect">
-            <a:avLst/>
-          </a:prstGeom>
-          <a:noFill/>
-          <a:ln/>
-        </p:spPr>
-        <p:txBody>
-          <a:bodyPr wrap="square" lIns="0" tIns="0" rIns="0" bIns="0" rtlCol="0" anchor="t"/>
-          <a:lstStyle/>
-          <a:p>
-            <a:pPr indent="0" marL="0">
-              <a:lnSpc>
-                <a:spcPct val="125000"/>
-              </a:lnSpc>
+            <a:pPr algn="r" indent="0" marL="0">
               <a:buNone/>
             </a:pPr>
             <a:r>
               <a:rPr lang="en-US" sz="2000" dirty="0">
                 <a:solidFill>
-                  <a:srgbClr val="CADCE8"/>
+                  <a:srgbClr val="5B6B84"/>
                 </a:solidFill>
                 <a:latin typeface="Calibri" pitchFamily="34" charset="0"/>
                 <a:ea typeface="Calibri" pitchFamily="34" charset="-122"/>
                 <a:cs typeface="Calibri" pitchFamily="34" charset="-120"/>
               </a:rPr>
-              <a:t>Swap "DriveModule/" for "Elevator/", rebuild, and watch a new folder appear in the tree.</a:t>
-            </a:r>
-            <a:endParaRPr lang="en-US" sz="2000" dirty="0"/>
-          </a:p>
-        </p:txBody>
-      </p:sp>
-      <p:sp>
-        <p:nvSpPr>
-          <p:cNvPr id="21" name="Shape 18"/>
-          <p:cNvSpPr/>
-          <p:nvPr/>
-        </p:nvSpPr>
-        <p:spPr>
-          <a:xfrm>
-            <a:off x="6217920" y="4023360"/>
-            <a:ext cx="5303520" cy="2286000"/>
-          </a:xfrm>
-          <a:prstGeom prst="roundRect">
-            <a:avLst>
-              <a:gd name="adj" fmla="val 4800"/>
-            </a:avLst>
-          </a:prstGeom>
-          <a:solidFill>
-            <a:srgbClr val="132A4C"/>
-          </a:solidFill>
-          <a:ln/>
-        </p:spPr>
-      </p:sp>
-      <p:sp>
-        <p:nvSpPr>
-          <p:cNvPr id="22" name="Shape 19"/>
-          <p:cNvSpPr/>
-          <p:nvPr/>
-        </p:nvSpPr>
-        <p:spPr>
-          <a:xfrm>
-            <a:off x="6537960" y="4251960"/>
-            <a:ext cx="457200" cy="457200"/>
-          </a:xfrm>
-          <a:prstGeom prst="ellipse">
-            <a:avLst/>
-          </a:prstGeom>
-          <a:solidFill>
-            <a:srgbClr val="1B9AAA"/>
-          </a:solidFill>
-          <a:ln/>
-        </p:spPr>
-      </p:sp>
-      <p:sp>
-        <p:nvSpPr>
-          <p:cNvPr id="23" name="Text 20"/>
-          <p:cNvSpPr/>
-          <p:nvPr/>
-        </p:nvSpPr>
-        <p:spPr>
-          <a:xfrm>
-            <a:off x="6537960" y="4251960"/>
-            <a:ext cx="457200" cy="457200"/>
-          </a:xfrm>
-          <a:prstGeom prst="rect">
-            <a:avLst/>
-          </a:prstGeom>
-          <a:noFill/>
-          <a:ln/>
-        </p:spPr>
-        <p:txBody>
-          <a:bodyPr wrap="square" lIns="0" tIns="0" rIns="0" bIns="0" rtlCol="0" anchor="ctr"/>
-          <a:lstStyle/>
-          <a:p>
-            <a:pPr algn="ctr" indent="0" marL="0">
-              <a:buNone/>
-            </a:pPr>
-            <a:r>
-              <a:rPr lang="en-US" sz="2200" b="1" dirty="0">
-                <a:solidFill>
-                  <a:srgbClr val="FFFFFF"/>
-                </a:solidFill>
-                <a:latin typeface="Cambria" pitchFamily="34" charset="0"/>
-                <a:ea typeface="Cambria" pitchFamily="34" charset="-122"/>
-                <a:cs typeface="Cambria" pitchFamily="34" charset="-120"/>
-              </a:rPr>
-              <a:t>4</a:t>
-            </a:r>
-            <a:endParaRPr lang="en-US" sz="2200" dirty="0"/>
-          </a:p>
-        </p:txBody>
-      </p:sp>
-      <p:sp>
-        <p:nvSpPr>
-          <p:cNvPr id="24" name="Text 21"/>
-          <p:cNvSpPr/>
-          <p:nvPr/>
-        </p:nvSpPr>
-        <p:spPr>
-          <a:xfrm>
-            <a:off x="7178040" y="4251960"/>
-            <a:ext cx="4023360" cy="457200"/>
-          </a:xfrm>
-          <a:prstGeom prst="rect">
-            <a:avLst/>
-          </a:prstGeom>
-          <a:noFill/>
-          <a:ln/>
-        </p:spPr>
-        <p:txBody>
-          <a:bodyPr wrap="square" lIns="0" tIns="0" rIns="0" bIns="0" rtlCol="0" anchor="ctr"/>
-          <a:lstStyle/>
-          <a:p>
-            <a:pPr indent="0" marL="0">
-              <a:lnSpc>
-                <a:spcPct val="110000"/>
-              </a:lnSpc>
-              <a:buNone/>
-            </a:pPr>
-            <a:r>
-              <a:rPr lang="en-US" sz="2000" b="1" dirty="0">
-                <a:solidFill>
-                  <a:srgbClr val="FFFFFF"/>
-                </a:solidFill>
-                <a:latin typeface="Cambria" pitchFamily="34" charset="0"/>
-                <a:ea typeface="Cambria" pitchFamily="34" charset="-122"/>
-                <a:cs typeface="Cambria" pitchFamily="34" charset="-120"/>
-              </a:rPr>
-              <a:t>Log when a command completes</a:t>
-            </a:r>
-            <a:endParaRPr lang="en-US" sz="2000" dirty="0"/>
-          </a:p>
-        </p:txBody>
-      </p:sp>
-      <p:sp>
-        <p:nvSpPr>
-          <p:cNvPr id="25" name="Text 22"/>
-          <p:cNvSpPr/>
-          <p:nvPr/>
-        </p:nvSpPr>
-        <p:spPr>
-          <a:xfrm>
-            <a:off x="6537960" y="4846320"/>
-            <a:ext cx="4663440" cy="1188720"/>
-          </a:xfrm>
-          <a:prstGeom prst="rect">
-            <a:avLst/>
-          </a:prstGeom>
-          <a:noFill/>
-          <a:ln/>
-        </p:spPr>
-        <p:txBody>
-          <a:bodyPr wrap="square" lIns="0" tIns="0" rIns="0" bIns="0" rtlCol="0" anchor="t"/>
-          <a:lstStyle/>
-          <a:p>
-            <a:pPr indent="0" marL="0">
-              <a:lnSpc>
-                <a:spcPct val="125000"/>
-              </a:lnSpc>
-              <a:buNone/>
-            </a:pPr>
-            <a:r>
-              <a:rPr lang="en-US" sz="2000" dirty="0">
-                <a:solidFill>
-                  <a:srgbClr val="CADCE8"/>
-                </a:solidFill>
-                <a:latin typeface="Calibri" pitchFamily="34" charset="0"/>
-                <a:ea typeface="Calibri" pitchFamily="34" charset="-122"/>
-                <a:cs typeface="Calibri" pitchFamily="34" charset="-120"/>
-              </a:rPr>
-              <a:t>Handle SchedulerEvent.Completed and write LastCompletedCommand.</a:t>
-            </a:r>
-            <a:endParaRPr lang="en-US" sz="2000" dirty="0"/>
-          </a:p>
-        </p:txBody>
-      </p:sp>
-      <p:sp>
-        <p:nvSpPr>
-          <p:cNvPr id="26" name="Text 23"/>
-          <p:cNvSpPr/>
-          <p:nvPr/>
-        </p:nvSpPr>
-        <p:spPr>
-          <a:xfrm>
-            <a:off x="640080" y="6446520"/>
-            <a:ext cx="8229600" cy="365760"/>
-          </a:xfrm>
-          <a:prstGeom prst="rect">
-            <a:avLst/>
-          </a:prstGeom>
-          <a:noFill/>
-          <a:ln/>
-        </p:spPr>
-        <p:txBody>
-          <a:bodyPr wrap="square" lIns="0" tIns="0" rIns="0" bIns="0" rtlCol="0" anchor="ctr"/>
-          <a:lstStyle/>
-          <a:p>
-            <a:pPr indent="0" marL="0">
-              <a:buNone/>
-            </a:pPr>
-            <a:r>
-              <a:rPr lang="en-US" sz="2000" spc="100" kern="0" dirty="0">
-                <a:solidFill>
-                  <a:srgbClr val="7A93B8"/>
-                </a:solidFill>
-                <a:latin typeface="Calibri" pitchFamily="34" charset="0"/>
-                <a:ea typeface="Calibri" pitchFamily="34" charset="-122"/>
-                <a:cs typeface="Calibri" pitchFamily="34" charset="-120"/>
-              </a:rPr>
-              <a:t>LEARN JAVA + ROBOT PROGRAMMING · TELEMETRY</a:t>
-            </a:r>
-            <a:endParaRPr lang="en-US" sz="2000" dirty="0"/>
-          </a:p>
-        </p:txBody>
-      </p:sp>
-      <p:sp>
-        <p:nvSpPr>
-          <p:cNvPr id="27" name="Text 24"/>
-          <p:cNvSpPr/>
-          <p:nvPr/>
-        </p:nvSpPr>
-        <p:spPr>
-          <a:xfrm>
-            <a:off x="11002975" y="6446520"/>
-            <a:ext cx="548640" cy="365760"/>
-          </a:xfrm>
-          <a:prstGeom prst="rect">
-            <a:avLst/>
-          </a:prstGeom>
-          <a:noFill/>
-          <a:ln/>
-        </p:spPr>
-        <p:txBody>
-          <a:bodyPr wrap="square" lIns="0" tIns="0" rIns="0" bIns="0" rtlCol="0" anchor="ctr"/>
-          <a:lstStyle/>
-          <a:p>
-            <a:pPr algn="r" indent="0" marL="0">
-              <a:buNone/>
-            </a:pPr>
-            <a:r>
-              <a:rPr lang="en-US" sz="2000" dirty="0">
-                <a:solidFill>
-                  <a:srgbClr val="7A93B8"/>
-                </a:solidFill>
-                <a:latin typeface="Calibri" pitchFamily="34" charset="0"/>
-                <a:ea typeface="Calibri" pitchFamily="34" charset="-122"/>
-                <a:cs typeface="Calibri" pitchFamily="34" charset="-120"/>
-              </a:rPr>
               <a:t>9</a:t>
             </a:r>
             <a:endParaRPr lang="en-US" sz="2000" dirty="0"/>
@@ -8027,7 +9050,7 @@
       </p:sp>
       <p:pic>
         <p:nvPicPr>
-          <p:cNvPr id="28" name="Image 1" descr="/home/user/BasicRobotLessons/docs/presentations/v3/template/assets/logo/team5010-logo-onnavy.png">    </p:cNvPr>
+          <p:cNvPr id="17" name="Image 1" descr="/home/user/BasicRobotLessons/docs/presentations/v3/template/assets/logo/team5010-logo-onwhite.png">    </p:cNvPr>
           <p:cNvPicPr>
             <a:picLocks noChangeAspect="1"/>
           </p:cNvPicPr>

</xml_diff>